<commit_message>
Fix slide 13 results table overflowing past slide edge
The DM/IPS/SNIPS/DR results table extended to x=10.46in on a 10in-wide
slide, clipping the Width column. Scaled the table shapes down to fit
within the slide bounds.
</commit_message>
<xml_diff>
--- a/presentation/OPE_Prezentacja_v2.pptx
+++ b/presentation/OPE_Prezentacja_v2.pptx
@@ -3789,7 +3789,7 @@
         <p:spPr>
           <a:xfrm>
             <a:off x="5349240" y="1234440"/>
-            <a:ext cx="731520" cy="384048"/>
+            <a:ext cx="623616" cy="384048"/>
           </a:xfrm>
           <a:prstGeom prst="rect">
             <a:avLst/>
@@ -3813,8 +3813,8 @@
         </p:nvSpPr>
         <p:spPr>
           <a:xfrm>
-            <a:off x="5385816" y="1234440"/>
-            <a:ext cx="694944" cy="384048"/>
+            <a:off x="5380420" y="1234440"/>
+            <a:ext cx="592435" cy="384048"/>
           </a:xfrm>
           <a:prstGeom prst="rect">
             <a:avLst/>
@@ -3852,8 +3852,8 @@
         </p:nvSpPr>
         <p:spPr>
           <a:xfrm>
-            <a:off x="6080760" y="1234440"/>
-            <a:ext cx="804672" cy="384048"/>
+            <a:off x="5972856" y="1234440"/>
+            <a:ext cx="685978" cy="384048"/>
           </a:xfrm>
           <a:prstGeom prst="rect">
             <a:avLst/>
@@ -3877,8 +3877,8 @@
         </p:nvSpPr>
         <p:spPr>
           <a:xfrm>
-            <a:off x="6117336" y="1234440"/>
-            <a:ext cx="768096" cy="384048"/>
+            <a:off x="6004037" y="1234440"/>
+            <a:ext cx="654797" cy="384048"/>
           </a:xfrm>
           <a:prstGeom prst="rect">
             <a:avLst/>
@@ -3916,8 +3916,8 @@
         </p:nvSpPr>
         <p:spPr>
           <a:xfrm>
-            <a:off x="6885432" y="1234440"/>
-            <a:ext cx="1810512" cy="384048"/>
+            <a:off x="6658835" y="1234440"/>
+            <a:ext cx="1543451" cy="384048"/>
           </a:xfrm>
           <a:prstGeom prst="rect">
             <a:avLst/>
@@ -3941,8 +3941,8 @@
         </p:nvSpPr>
         <p:spPr>
           <a:xfrm>
-            <a:off x="6922008" y="1234440"/>
-            <a:ext cx="1773936" cy="384048"/>
+            <a:off x="6690016" y="1234440"/>
+            <a:ext cx="1512270" cy="384048"/>
           </a:xfrm>
           <a:prstGeom prst="rect">
             <a:avLst/>
@@ -3980,8 +3980,8 @@
         </p:nvSpPr>
         <p:spPr>
           <a:xfrm>
-            <a:off x="8695944" y="1234440"/>
-            <a:ext cx="868680" cy="384048"/>
+            <a:off x="8202287" y="1234440"/>
+            <a:ext cx="740544" cy="384048"/>
           </a:xfrm>
           <a:prstGeom prst="rect">
             <a:avLst/>
@@ -4005,8 +4005,8 @@
         </p:nvSpPr>
         <p:spPr>
           <a:xfrm>
-            <a:off x="8732520" y="1234440"/>
-            <a:ext cx="832104" cy="384048"/>
+            <a:off x="8233467" y="1234440"/>
+            <a:ext cx="709364" cy="384048"/>
           </a:xfrm>
           <a:prstGeom prst="rect">
             <a:avLst/>
@@ -4045,7 +4045,7 @@
         <p:spPr>
           <a:xfrm>
             <a:off x="5349240" y="1618488"/>
-            <a:ext cx="731520" cy="493776"/>
+            <a:ext cx="623616" cy="493776"/>
           </a:xfrm>
           <a:prstGeom prst="rect">
             <a:avLst/>
@@ -4070,7 +4070,7 @@
         <p:spPr>
           <a:xfrm>
             <a:off x="5349240" y="1618488"/>
-            <a:ext cx="54864" cy="493776"/>
+            <a:ext cx="46771" cy="493776"/>
           </a:xfrm>
           <a:prstGeom prst="rect">
             <a:avLst/>
@@ -4094,8 +4094,8 @@
         </p:nvSpPr>
         <p:spPr>
           <a:xfrm>
-            <a:off x="5458968" y="1618488"/>
-            <a:ext cx="640080" cy="493776"/>
+            <a:off x="5442782" y="1618488"/>
+            <a:ext cx="545664" cy="493776"/>
           </a:xfrm>
           <a:prstGeom prst="rect">
             <a:avLst/>
@@ -4133,8 +4133,8 @@
         </p:nvSpPr>
         <p:spPr>
           <a:xfrm>
-            <a:off x="6080760" y="1618488"/>
-            <a:ext cx="804672" cy="493776"/>
+            <a:off x="5972856" y="1618488"/>
+            <a:ext cx="685978" cy="493776"/>
           </a:xfrm>
           <a:prstGeom prst="rect">
             <a:avLst/>
@@ -4158,8 +4158,8 @@
         </p:nvSpPr>
         <p:spPr>
           <a:xfrm>
-            <a:off x="6126480" y="1618488"/>
-            <a:ext cx="713232" cy="493776"/>
+            <a:off x="6011832" y="1618488"/>
+            <a:ext cx="608026" cy="493776"/>
           </a:xfrm>
           <a:prstGeom prst="rect">
             <a:avLst/>
@@ -4197,8 +4197,8 @@
         </p:nvSpPr>
         <p:spPr>
           <a:xfrm>
-            <a:off x="6885432" y="1618488"/>
-            <a:ext cx="1810512" cy="493776"/>
+            <a:off x="6658835" y="1618488"/>
+            <a:ext cx="1543451" cy="493776"/>
           </a:xfrm>
           <a:prstGeom prst="rect">
             <a:avLst/>
@@ -4222,8 +4222,8 @@
         </p:nvSpPr>
         <p:spPr>
           <a:xfrm>
-            <a:off x="6931152" y="1618488"/>
-            <a:ext cx="1719072" cy="493776"/>
+            <a:off x="6697811" y="1618488"/>
+            <a:ext cx="1465499" cy="493776"/>
           </a:xfrm>
           <a:prstGeom prst="rect">
             <a:avLst/>
@@ -4261,8 +4261,8 @@
         </p:nvSpPr>
         <p:spPr>
           <a:xfrm>
-            <a:off x="8695944" y="1618488"/>
-            <a:ext cx="868680" cy="493776"/>
+            <a:off x="8202287" y="1618488"/>
+            <a:ext cx="740544" cy="493776"/>
           </a:xfrm>
           <a:prstGeom prst="rect">
             <a:avLst/>
@@ -4286,8 +4286,8 @@
         </p:nvSpPr>
         <p:spPr>
           <a:xfrm>
-            <a:off x="8741664" y="1618488"/>
-            <a:ext cx="777240" cy="493776"/>
+            <a:off x="8241263" y="1618488"/>
+            <a:ext cx="662592" cy="493776"/>
           </a:xfrm>
           <a:prstGeom prst="rect">
             <a:avLst/>
@@ -4326,7 +4326,7 @@
         <p:spPr>
           <a:xfrm>
             <a:off x="5349240" y="2112264"/>
-            <a:ext cx="731520" cy="493776"/>
+            <a:ext cx="623616" cy="493776"/>
           </a:xfrm>
           <a:prstGeom prst="rect">
             <a:avLst/>
@@ -4351,7 +4351,7 @@
         <p:spPr>
           <a:xfrm>
             <a:off x="5349240" y="2112264"/>
-            <a:ext cx="54864" cy="493776"/>
+            <a:ext cx="46771" cy="493776"/>
           </a:xfrm>
           <a:prstGeom prst="rect">
             <a:avLst/>
@@ -4375,8 +4375,8 @@
         </p:nvSpPr>
         <p:spPr>
           <a:xfrm>
-            <a:off x="5458968" y="2112264"/>
-            <a:ext cx="640080" cy="493776"/>
+            <a:off x="5442782" y="2112264"/>
+            <a:ext cx="545664" cy="493776"/>
           </a:xfrm>
           <a:prstGeom prst="rect">
             <a:avLst/>
@@ -4414,8 +4414,8 @@
         </p:nvSpPr>
         <p:spPr>
           <a:xfrm>
-            <a:off x="6080760" y="2112264"/>
-            <a:ext cx="804672" cy="493776"/>
+            <a:off x="5972856" y="2112264"/>
+            <a:ext cx="685978" cy="493776"/>
           </a:xfrm>
           <a:prstGeom prst="rect">
             <a:avLst/>
@@ -4439,8 +4439,8 @@
         </p:nvSpPr>
         <p:spPr>
           <a:xfrm>
-            <a:off x="6126480" y="2112264"/>
-            <a:ext cx="713232" cy="493776"/>
+            <a:off x="6011832" y="2112264"/>
+            <a:ext cx="608026" cy="493776"/>
           </a:xfrm>
           <a:prstGeom prst="rect">
             <a:avLst/>
@@ -4478,8 +4478,8 @@
         </p:nvSpPr>
         <p:spPr>
           <a:xfrm>
-            <a:off x="6885432" y="2112264"/>
-            <a:ext cx="1810512" cy="493776"/>
+            <a:off x="6658835" y="2112264"/>
+            <a:ext cx="1543451" cy="493776"/>
           </a:xfrm>
           <a:prstGeom prst="rect">
             <a:avLst/>
@@ -4503,8 +4503,8 @@
         </p:nvSpPr>
         <p:spPr>
           <a:xfrm>
-            <a:off x="6931152" y="2112264"/>
-            <a:ext cx="1719072" cy="493776"/>
+            <a:off x="6697811" y="2112264"/>
+            <a:ext cx="1465499" cy="493776"/>
           </a:xfrm>
           <a:prstGeom prst="rect">
             <a:avLst/>
@@ -4542,8 +4542,8 @@
         </p:nvSpPr>
         <p:spPr>
           <a:xfrm>
-            <a:off x="8695944" y="2112264"/>
-            <a:ext cx="868680" cy="493776"/>
+            <a:off x="8202287" y="2112264"/>
+            <a:ext cx="740544" cy="493776"/>
           </a:xfrm>
           <a:prstGeom prst="rect">
             <a:avLst/>
@@ -4567,8 +4567,8 @@
         </p:nvSpPr>
         <p:spPr>
           <a:xfrm>
-            <a:off x="8741664" y="2112264"/>
-            <a:ext cx="777240" cy="493776"/>
+            <a:off x="8241263" y="2112264"/>
+            <a:ext cx="662592" cy="493776"/>
           </a:xfrm>
           <a:prstGeom prst="rect">
             <a:avLst/>
@@ -4607,7 +4607,7 @@
         <p:spPr>
           <a:xfrm>
             <a:off x="5349240" y="2606040"/>
-            <a:ext cx="731520" cy="493776"/>
+            <a:ext cx="623616" cy="493776"/>
           </a:xfrm>
           <a:prstGeom prst="rect">
             <a:avLst/>
@@ -4632,7 +4632,7 @@
         <p:spPr>
           <a:xfrm>
             <a:off x="5349240" y="2606040"/>
-            <a:ext cx="54864" cy="493776"/>
+            <a:ext cx="46771" cy="493776"/>
           </a:xfrm>
           <a:prstGeom prst="rect">
             <a:avLst/>
@@ -4656,8 +4656,8 @@
         </p:nvSpPr>
         <p:spPr>
           <a:xfrm>
-            <a:off x="5458968" y="2606040"/>
-            <a:ext cx="640080" cy="493776"/>
+            <a:off x="5442782" y="2606040"/>
+            <a:ext cx="545664" cy="493776"/>
           </a:xfrm>
           <a:prstGeom prst="rect">
             <a:avLst/>
@@ -4695,8 +4695,8 @@
         </p:nvSpPr>
         <p:spPr>
           <a:xfrm>
-            <a:off x="6080760" y="2606040"/>
-            <a:ext cx="804672" cy="493776"/>
+            <a:off x="5972856" y="2606040"/>
+            <a:ext cx="685978" cy="493776"/>
           </a:xfrm>
           <a:prstGeom prst="rect">
             <a:avLst/>
@@ -4720,8 +4720,8 @@
         </p:nvSpPr>
         <p:spPr>
           <a:xfrm>
-            <a:off x="6126480" y="2606040"/>
-            <a:ext cx="713232" cy="493776"/>
+            <a:off x="6011832" y="2606040"/>
+            <a:ext cx="608026" cy="493776"/>
           </a:xfrm>
           <a:prstGeom prst="rect">
             <a:avLst/>
@@ -4759,8 +4759,8 @@
         </p:nvSpPr>
         <p:spPr>
           <a:xfrm>
-            <a:off x="6885432" y="2606040"/>
-            <a:ext cx="1810512" cy="493776"/>
+            <a:off x="6658835" y="2606040"/>
+            <a:ext cx="1543451" cy="493776"/>
           </a:xfrm>
           <a:prstGeom prst="rect">
             <a:avLst/>
@@ -4784,8 +4784,8 @@
         </p:nvSpPr>
         <p:spPr>
           <a:xfrm>
-            <a:off x="6931152" y="2606040"/>
-            <a:ext cx="1719072" cy="493776"/>
+            <a:off x="6697811" y="2606040"/>
+            <a:ext cx="1465499" cy="493776"/>
           </a:xfrm>
           <a:prstGeom prst="rect">
             <a:avLst/>
@@ -4823,8 +4823,8 @@
         </p:nvSpPr>
         <p:spPr>
           <a:xfrm>
-            <a:off x="8695944" y="2606040"/>
-            <a:ext cx="868680" cy="493776"/>
+            <a:off x="8202287" y="2606040"/>
+            <a:ext cx="740544" cy="493776"/>
           </a:xfrm>
           <a:prstGeom prst="rect">
             <a:avLst/>
@@ -4848,8 +4848,8 @@
         </p:nvSpPr>
         <p:spPr>
           <a:xfrm>
-            <a:off x="8741664" y="2606040"/>
-            <a:ext cx="777240" cy="493776"/>
+            <a:off x="8241263" y="2606040"/>
+            <a:ext cx="662592" cy="493776"/>
           </a:xfrm>
           <a:prstGeom prst="rect">
             <a:avLst/>
@@ -4888,7 +4888,7 @@
         <p:spPr>
           <a:xfrm>
             <a:off x="5349240" y="3099816"/>
-            <a:ext cx="731520" cy="493776"/>
+            <a:ext cx="623616" cy="493776"/>
           </a:xfrm>
           <a:prstGeom prst="rect">
             <a:avLst/>
@@ -4913,7 +4913,7 @@
         <p:spPr>
           <a:xfrm>
             <a:off x="5349240" y="3099816"/>
-            <a:ext cx="54864" cy="493776"/>
+            <a:ext cx="46771" cy="493776"/>
           </a:xfrm>
           <a:prstGeom prst="rect">
             <a:avLst/>
@@ -4937,8 +4937,8 @@
         </p:nvSpPr>
         <p:spPr>
           <a:xfrm>
-            <a:off x="5458968" y="3099816"/>
-            <a:ext cx="640080" cy="493776"/>
+            <a:off x="5442782" y="3099816"/>
+            <a:ext cx="545664" cy="493776"/>
           </a:xfrm>
           <a:prstGeom prst="rect">
             <a:avLst/>
@@ -4976,8 +4976,8 @@
         </p:nvSpPr>
         <p:spPr>
           <a:xfrm>
-            <a:off x="6080760" y="3099816"/>
-            <a:ext cx="804672" cy="493776"/>
+            <a:off x="5972856" y="3099816"/>
+            <a:ext cx="685978" cy="493776"/>
           </a:xfrm>
           <a:prstGeom prst="rect">
             <a:avLst/>
@@ -5001,8 +5001,8 @@
         </p:nvSpPr>
         <p:spPr>
           <a:xfrm>
-            <a:off x="6126480" y="3099816"/>
-            <a:ext cx="713232" cy="493776"/>
+            <a:off x="6011832" y="3099816"/>
+            <a:ext cx="608026" cy="493776"/>
           </a:xfrm>
           <a:prstGeom prst="rect">
             <a:avLst/>
@@ -5040,8 +5040,8 @@
         </p:nvSpPr>
         <p:spPr>
           <a:xfrm>
-            <a:off x="6885432" y="3099816"/>
-            <a:ext cx="1810512" cy="493776"/>
+            <a:off x="6658835" y="3099816"/>
+            <a:ext cx="1543451" cy="493776"/>
           </a:xfrm>
           <a:prstGeom prst="rect">
             <a:avLst/>
@@ -5065,8 +5065,8 @@
         </p:nvSpPr>
         <p:spPr>
           <a:xfrm>
-            <a:off x="6931152" y="3099816"/>
-            <a:ext cx="1719072" cy="493776"/>
+            <a:off x="6697811" y="3099816"/>
+            <a:ext cx="1465499" cy="493776"/>
           </a:xfrm>
           <a:prstGeom prst="rect">
             <a:avLst/>
@@ -5104,8 +5104,8 @@
         </p:nvSpPr>
         <p:spPr>
           <a:xfrm>
-            <a:off x="8695944" y="3099816"/>
-            <a:ext cx="868680" cy="493776"/>
+            <a:off x="8202287" y="3099816"/>
+            <a:ext cx="740544" cy="493776"/>
           </a:xfrm>
           <a:prstGeom prst="rect">
             <a:avLst/>
@@ -5129,8 +5129,8 @@
         </p:nvSpPr>
         <p:spPr>
           <a:xfrm>
-            <a:off x="8741664" y="3099816"/>
-            <a:ext cx="777240" cy="493776"/>
+            <a:off x="8241263" y="3099816"/>
+            <a:ext cx="662592" cy="493776"/>
           </a:xfrm>
           <a:prstGeom prst="rect">
             <a:avLst/>
@@ -5169,7 +5169,7 @@
         <p:spPr>
           <a:xfrm>
             <a:off x="5349240" y="4187952"/>
-            <a:ext cx="3584448" cy="457200"/>
+            <a:ext cx="3055722" cy="457200"/>
           </a:xfrm>
           <a:prstGeom prst="rect">
             <a:avLst/>

</xml_diff>

<commit_message>
update oraz ustrukturyzowanie kodu
</commit_message>
<xml_diff>
--- a/presentation/OPE_Prezentacja_v2.pptx
+++ b/presentation/OPE_Prezentacja_v2.pptx
@@ -22,6 +22,7 @@
     <p:sldId id="270" r:id="rId16"/>
     <p:sldId id="271" r:id="rId17"/>
     <p:sldId id="272" r:id="rId18"/>
+    <p:sldId id="274" r:id="rId25"/>
     <p:sldId id="273" r:id="rId19"/>
   </p:sldIdLst>
   <p:notesMasterIdLst>
@@ -8705,6 +8706,4366 @@
               <a:t>Dalsze kroki: pełny StatsBomb (38 kolejek × 5 sezonów)  ·  Continuous treatment  ·  Q-function dla RL  ·  v1.0</a:t>
             </a:r>
             <a:endParaRPr lang="en-US" sz="1000" dirty="0"/>
+          </a:p>
+        </p:txBody>
+      </p:sp>
+    </p:spTree>
+  </p:cSld>
+  <p:clrMapOvr>
+    <a:masterClrMapping/>
+  </p:clrMapOvr>
+</p:sld>
+</file>
+
+<file path=ppt/slides/slide19.xml><?xml version="1.0" encoding="utf-8"?>
+<p:sld xmlns:a="http://schemas.openxmlformats.org/drawingml/2006/main" xmlns:p="http://schemas.openxmlformats.org/presentationml/2006/main" xmlns:r="http://schemas.openxmlformats.org/officeDocument/2006/relationships">
+  <p:cSld>
+    <p:spTree>
+      <p:nvGrpSpPr>
+        <p:cNvPr id="1" name=""/>
+        <p:cNvGrpSpPr/>
+        <p:nvPr/>
+      </p:nvGrpSpPr>
+      <p:grpSpPr/>
+      <p:sp>
+        <p:nvSpPr>
+          <p:cNvPr id="2" name="Rectangle 1"/>
+          <p:cNvSpPr/>
+          <p:nvPr/>
+        </p:nvSpPr>
+        <p:spPr>
+          <a:xfrm>
+            <a:off x="0" y="0"/>
+            <a:ext cx="109728" cy="5143500"/>
+          </a:xfrm>
+          <a:prstGeom prst="rect">
+            <a:avLst/>
+          </a:prstGeom>
+          <a:solidFill>
+            <a:srgbClr val="0A7B83"/>
+          </a:solidFill>
+          <a:ln w="12700">
+            <a:solidFill>
+              <a:srgbClr val="0A7B83"/>
+            </a:solidFill>
+          </a:ln>
+          <a:effectLst/>
+        </p:spPr>
+        <p:style>
+          <a:lnRef idx="1">
+            <a:schemeClr val="accent1"/>
+          </a:lnRef>
+          <a:fillRef idx="3">
+            <a:schemeClr val="accent1"/>
+          </a:fillRef>
+          <a:effectRef idx="2">
+            <a:schemeClr val="accent1"/>
+          </a:effectRef>
+          <a:fontRef idx="minor">
+            <a:schemeClr val="lt1"/>
+          </a:fontRef>
+        </p:style>
+        <p:txBody>
+          <a:bodyPr rtlCol="0" anchor="ctr"/>
+          <a:lstStyle/>
+          <a:p>
+            <a:pPr algn="ctr"/>
+          </a:p>
+        </p:txBody>
+      </p:sp>
+      <p:sp>
+        <p:nvSpPr>
+          <p:cNvPr id="3" name="Rectangle 2"/>
+          <p:cNvSpPr/>
+          <p:nvPr/>
+        </p:nvSpPr>
+        <p:spPr>
+          <a:xfrm>
+            <a:off x="164592" y="118872"/>
+            <a:ext cx="2286000" cy="237744"/>
+          </a:xfrm>
+          <a:prstGeom prst="rect">
+            <a:avLst/>
+          </a:prstGeom>
+          <a:solidFill>
+            <a:srgbClr val="8E44AD"/>
+          </a:solidFill>
+          <a:ln w="12700">
+            <a:solidFill>
+              <a:srgbClr val="8E44AD"/>
+            </a:solidFill>
+          </a:ln>
+          <a:effectLst/>
+        </p:spPr>
+        <p:style>
+          <a:lnRef idx="1">
+            <a:schemeClr val="accent1"/>
+          </a:lnRef>
+          <a:fillRef idx="3">
+            <a:schemeClr val="accent1"/>
+          </a:fillRef>
+          <a:effectRef idx="2">
+            <a:schemeClr val="accent1"/>
+          </a:effectRef>
+          <a:fontRef idx="minor">
+            <a:schemeClr val="lt1"/>
+          </a:fontRef>
+        </p:style>
+        <p:txBody>
+          <a:bodyPr rtlCol="0" anchor="ctr"/>
+          <a:lstStyle/>
+          <a:p>
+            <a:pPr algn="ctr"/>
+          </a:p>
+        </p:txBody>
+      </p:sp>
+      <p:sp>
+        <p:nvSpPr>
+          <p:cNvPr id="4" name="Rectangle 3"/>
+          <p:cNvSpPr/>
+          <p:nvPr/>
+        </p:nvSpPr>
+        <p:spPr>
+          <a:xfrm>
+            <a:off x="164592" y="109728"/>
+            <a:ext cx="2286000" cy="256032"/>
+          </a:xfrm>
+          <a:prstGeom prst="rect">
+            <a:avLst/>
+          </a:prstGeom>
+          <a:noFill/>
+          <a:ln>
+            <a:noFill/>
+          </a:ln>
+          <a:effectLst/>
+        </p:spPr>
+        <p:style>
+          <a:lnRef idx="1">
+            <a:schemeClr val="accent1"/>
+          </a:lnRef>
+          <a:fillRef idx="3">
+            <a:schemeClr val="accent1"/>
+          </a:fillRef>
+          <a:effectRef idx="2">
+            <a:schemeClr val="accent1"/>
+          </a:effectRef>
+          <a:fontRef idx="minor">
+            <a:schemeClr val="lt1"/>
+          </a:fontRef>
+        </p:style>
+        <p:txBody>
+          <a:bodyPr rtlCol="0" anchor="ctr" wrap="none" lIns="0" rIns="0" tIns="0" bIns="0"/>
+          <a:lstStyle/>
+          <a:p>
+            <a:pPr algn="ctr"/>
+            <a:r>
+              <a:rPr sz="850" b="1">
+                <a:solidFill>
+                  <a:srgbClr val="FFFFFF"/>
+                </a:solidFill>
+              </a:rPr>
+              <a:t>BLOK 9 · WALIDACJA SYNTETYCZNA</a:t>
+            </a:r>
+          </a:p>
+        </p:txBody>
+      </p:sp>
+      <p:sp>
+        <p:nvSpPr>
+          <p:cNvPr id="5" name="Rectangle 4"/>
+          <p:cNvSpPr/>
+          <p:nvPr/>
+        </p:nvSpPr>
+        <p:spPr>
+          <a:xfrm>
+            <a:off x="201168" y="457200"/>
+            <a:ext cx="8778240" cy="658368"/>
+          </a:xfrm>
+          <a:prstGeom prst="rect">
+            <a:avLst/>
+          </a:prstGeom>
+          <a:noFill/>
+          <a:ln>
+            <a:noFill/>
+          </a:ln>
+          <a:effectLst/>
+        </p:spPr>
+        <p:style>
+          <a:lnRef idx="1">
+            <a:schemeClr val="accent1"/>
+          </a:lnRef>
+          <a:fillRef idx="3">
+            <a:schemeClr val="accent1"/>
+          </a:fillRef>
+          <a:effectRef idx="2">
+            <a:schemeClr val="accent1"/>
+          </a:effectRef>
+          <a:fontRef idx="minor">
+            <a:schemeClr val="lt1"/>
+          </a:fontRef>
+        </p:style>
+        <p:txBody>
+          <a:bodyPr rtlCol="0" anchor="ctr" wrap="none" lIns="0" rIns="0" tIns="0" bIns="0"/>
+          <a:lstStyle/>
+          <a:p>
+            <a:pPr algn="l"/>
+            <a:r>
+              <a:rPr sz="2400" b="1">
+                <a:solidFill>
+                  <a:srgbClr val="0D1B2A"/>
+                </a:solidFill>
+                <a:latin typeface="Trebuchet MS"/>
+              </a:rPr>
+              <a:t>Walidacja syntetyczna — DR≈naive: sygnał czy artefakt?</a:t>
+            </a:r>
+          </a:p>
+        </p:txBody>
+      </p:sp>
+      <p:pic>
+        <p:nvPicPr>
+          <p:cNvPr id="6" name="Picture 5" descr="synthetic_validation.png"/>
+          <p:cNvPicPr>
+            <a:picLocks noChangeAspect="1"/>
+          </p:cNvPicPr>
+          <p:nvPr/>
+        </p:nvPicPr>
+        <p:blipFill>
+          <a:blip r:embed="rId2"/>
+          <a:stretch>
+            <a:fillRect/>
+          </a:stretch>
+        </p:blipFill>
+        <p:spPr>
+          <a:xfrm>
+            <a:off x="201168" y="1188720"/>
+            <a:ext cx="8741664" cy="2095906"/>
+          </a:xfrm>
+          <a:prstGeom prst="rect">
+            <a:avLst/>
+          </a:prstGeom>
+        </p:spPr>
+      </p:pic>
+      <p:sp>
+        <p:nvSpPr>
+          <p:cNvPr id="7" name="Rectangle 6"/>
+          <p:cNvSpPr/>
+          <p:nvPr/>
+        </p:nvSpPr>
+        <p:spPr>
+          <a:xfrm>
+            <a:off x="201168" y="3337560"/>
+            <a:ext cx="2331720" cy="256032"/>
+          </a:xfrm>
+          <a:prstGeom prst="rect">
+            <a:avLst/>
+          </a:prstGeom>
+          <a:solidFill>
+            <a:srgbClr val="0D1B2A"/>
+          </a:solidFill>
+          <a:ln w="12700">
+            <a:solidFill>
+              <a:srgbClr val="0D1B2A"/>
+            </a:solidFill>
+          </a:ln>
+          <a:effectLst/>
+        </p:spPr>
+        <p:style>
+          <a:lnRef idx="1">
+            <a:schemeClr val="accent1"/>
+          </a:lnRef>
+          <a:fillRef idx="3">
+            <a:schemeClr val="accent1"/>
+          </a:fillRef>
+          <a:effectRef idx="2">
+            <a:schemeClr val="accent1"/>
+          </a:effectRef>
+          <a:fontRef idx="minor">
+            <a:schemeClr val="lt1"/>
+          </a:fontRef>
+        </p:style>
+        <p:txBody>
+          <a:bodyPr rtlCol="0" anchor="ctr"/>
+          <a:lstStyle/>
+          <a:p>
+            <a:pPr algn="ctr"/>
+          </a:p>
+        </p:txBody>
+      </p:sp>
+      <p:sp>
+        <p:nvSpPr>
+          <p:cNvPr id="8" name="Rectangle 7"/>
+          <p:cNvSpPr/>
+          <p:nvPr/>
+        </p:nvSpPr>
+        <p:spPr>
+          <a:xfrm>
+            <a:off x="237744" y="3337560"/>
+            <a:ext cx="2258568" cy="256032"/>
+          </a:xfrm>
+          <a:prstGeom prst="rect">
+            <a:avLst/>
+          </a:prstGeom>
+          <a:noFill/>
+          <a:ln>
+            <a:noFill/>
+          </a:ln>
+          <a:effectLst/>
+        </p:spPr>
+        <p:style>
+          <a:lnRef idx="1">
+            <a:schemeClr val="accent1"/>
+          </a:lnRef>
+          <a:fillRef idx="3">
+            <a:schemeClr val="accent1"/>
+          </a:fillRef>
+          <a:effectRef idx="2">
+            <a:schemeClr val="accent1"/>
+          </a:effectRef>
+          <a:fontRef idx="minor">
+            <a:schemeClr val="lt1"/>
+          </a:fontRef>
+        </p:style>
+        <p:txBody>
+          <a:bodyPr rtlCol="0" anchor="ctr" wrap="none" lIns="0" rIns="0" tIns="0" bIns="0"/>
+          <a:lstStyle/>
+          <a:p>
+            <a:pPr algn="l"/>
+            <a:r>
+              <a:rPr sz="900" b="1">
+                <a:solidFill>
+                  <a:srgbClr val="FFFFFF"/>
+                </a:solidFill>
+                <a:latin typeface="Trebuchet MS"/>
+              </a:rPr>
+              <a:t>Scenariusz</a:t>
+            </a:r>
+          </a:p>
+        </p:txBody>
+      </p:sp>
+      <p:sp>
+        <p:nvSpPr>
+          <p:cNvPr id="9" name="Rectangle 8"/>
+          <p:cNvSpPr/>
+          <p:nvPr/>
+        </p:nvSpPr>
+        <p:spPr>
+          <a:xfrm>
+            <a:off x="2532888" y="3337560"/>
+            <a:ext cx="594360" cy="256032"/>
+          </a:xfrm>
+          <a:prstGeom prst="rect">
+            <a:avLst/>
+          </a:prstGeom>
+          <a:solidFill>
+            <a:srgbClr val="0D1B2A"/>
+          </a:solidFill>
+          <a:ln w="12700">
+            <a:solidFill>
+              <a:srgbClr val="0D1B2A"/>
+            </a:solidFill>
+          </a:ln>
+          <a:effectLst/>
+        </p:spPr>
+        <p:style>
+          <a:lnRef idx="1">
+            <a:schemeClr val="accent1"/>
+          </a:lnRef>
+          <a:fillRef idx="3">
+            <a:schemeClr val="accent1"/>
+          </a:fillRef>
+          <a:effectRef idx="2">
+            <a:schemeClr val="accent1"/>
+          </a:effectRef>
+          <a:fontRef idx="minor">
+            <a:schemeClr val="lt1"/>
+          </a:fontRef>
+        </p:style>
+        <p:txBody>
+          <a:bodyPr rtlCol="0" anchor="ctr"/>
+          <a:lstStyle/>
+          <a:p>
+            <a:pPr algn="ctr"/>
+          </a:p>
+        </p:txBody>
+      </p:sp>
+      <p:sp>
+        <p:nvSpPr>
+          <p:cNvPr id="10" name="Rectangle 9"/>
+          <p:cNvSpPr/>
+          <p:nvPr/>
+        </p:nvSpPr>
+        <p:spPr>
+          <a:xfrm>
+            <a:off x="2569464" y="3337560"/>
+            <a:ext cx="521208" cy="256032"/>
+          </a:xfrm>
+          <a:prstGeom prst="rect">
+            <a:avLst/>
+          </a:prstGeom>
+          <a:noFill/>
+          <a:ln>
+            <a:noFill/>
+          </a:ln>
+          <a:effectLst/>
+        </p:spPr>
+        <p:style>
+          <a:lnRef idx="1">
+            <a:schemeClr val="accent1"/>
+          </a:lnRef>
+          <a:fillRef idx="3">
+            <a:schemeClr val="accent1"/>
+          </a:fillRef>
+          <a:effectRef idx="2">
+            <a:schemeClr val="accent1"/>
+          </a:effectRef>
+          <a:fontRef idx="minor">
+            <a:schemeClr val="lt1"/>
+          </a:fontRef>
+        </p:style>
+        <p:txBody>
+          <a:bodyPr rtlCol="0" anchor="ctr" wrap="none" lIns="0" rIns="0" tIns="0" bIns="0"/>
+          <a:lstStyle/>
+          <a:p>
+            <a:pPr algn="l"/>
+            <a:r>
+              <a:rPr sz="900" b="1">
+                <a:solidFill>
+                  <a:srgbClr val="FFFFFF"/>
+                </a:solidFill>
+                <a:latin typeface="Trebuchet MS"/>
+              </a:rPr>
+              <a:t>ESS</a:t>
+            </a:r>
+          </a:p>
+        </p:txBody>
+      </p:sp>
+      <p:sp>
+        <p:nvSpPr>
+          <p:cNvPr id="11" name="Rectangle 10"/>
+          <p:cNvSpPr/>
+          <p:nvPr/>
+        </p:nvSpPr>
+        <p:spPr>
+          <a:xfrm>
+            <a:off x="3127248" y="3337560"/>
+            <a:ext cx="960120" cy="256032"/>
+          </a:xfrm>
+          <a:prstGeom prst="rect">
+            <a:avLst/>
+          </a:prstGeom>
+          <a:solidFill>
+            <a:srgbClr val="0D1B2A"/>
+          </a:solidFill>
+          <a:ln w="12700">
+            <a:solidFill>
+              <a:srgbClr val="0D1B2A"/>
+            </a:solidFill>
+          </a:ln>
+          <a:effectLst/>
+        </p:spPr>
+        <p:style>
+          <a:lnRef idx="1">
+            <a:schemeClr val="accent1"/>
+          </a:lnRef>
+          <a:fillRef idx="3">
+            <a:schemeClr val="accent1"/>
+          </a:fillRef>
+          <a:effectRef idx="2">
+            <a:schemeClr val="accent1"/>
+          </a:effectRef>
+          <a:fontRef idx="minor">
+            <a:schemeClr val="lt1"/>
+          </a:fontRef>
+        </p:style>
+        <p:txBody>
+          <a:bodyPr rtlCol="0" anchor="ctr"/>
+          <a:lstStyle/>
+          <a:p>
+            <a:pPr algn="ctr"/>
+          </a:p>
+        </p:txBody>
+      </p:sp>
+      <p:sp>
+        <p:nvSpPr>
+          <p:cNvPr id="12" name="Rectangle 11"/>
+          <p:cNvSpPr/>
+          <p:nvPr/>
+        </p:nvSpPr>
+        <p:spPr>
+          <a:xfrm>
+            <a:off x="3163824" y="3337560"/>
+            <a:ext cx="886968" cy="256032"/>
+          </a:xfrm>
+          <a:prstGeom prst="rect">
+            <a:avLst/>
+          </a:prstGeom>
+          <a:noFill/>
+          <a:ln>
+            <a:noFill/>
+          </a:ln>
+          <a:effectLst/>
+        </p:spPr>
+        <p:style>
+          <a:lnRef idx="1">
+            <a:schemeClr val="accent1"/>
+          </a:lnRef>
+          <a:fillRef idx="3">
+            <a:schemeClr val="accent1"/>
+          </a:fillRef>
+          <a:effectRef idx="2">
+            <a:schemeClr val="accent1"/>
+          </a:effectRef>
+          <a:fontRef idx="minor">
+            <a:schemeClr val="lt1"/>
+          </a:fontRef>
+        </p:style>
+        <p:txBody>
+          <a:bodyPr rtlCol="0" anchor="ctr" wrap="none" lIns="0" rIns="0" tIns="0" bIns="0"/>
+          <a:lstStyle/>
+          <a:p>
+            <a:pPr algn="l"/>
+            <a:r>
+              <a:rPr sz="900" b="1">
+                <a:solidFill>
+                  <a:srgbClr val="FFFFFF"/>
+                </a:solidFill>
+                <a:latin typeface="Trebuchet MS"/>
+              </a:rPr>
+              <a:t>Δ=V*−V_naive</a:t>
+            </a:r>
+          </a:p>
+        </p:txBody>
+      </p:sp>
+      <p:sp>
+        <p:nvSpPr>
+          <p:cNvPr id="13" name="Rectangle 12"/>
+          <p:cNvSpPr/>
+          <p:nvPr/>
+        </p:nvSpPr>
+        <p:spPr>
+          <a:xfrm>
+            <a:off x="4087368" y="3337560"/>
+            <a:ext cx="777240" cy="256032"/>
+          </a:xfrm>
+          <a:prstGeom prst="rect">
+            <a:avLst/>
+          </a:prstGeom>
+          <a:solidFill>
+            <a:srgbClr val="0D1B2A"/>
+          </a:solidFill>
+          <a:ln w="12700">
+            <a:solidFill>
+              <a:srgbClr val="0D1B2A"/>
+            </a:solidFill>
+          </a:ln>
+          <a:effectLst/>
+        </p:spPr>
+        <p:style>
+          <a:lnRef idx="1">
+            <a:schemeClr val="accent1"/>
+          </a:lnRef>
+          <a:fillRef idx="3">
+            <a:schemeClr val="accent1"/>
+          </a:fillRef>
+          <a:effectRef idx="2">
+            <a:schemeClr val="accent1"/>
+          </a:effectRef>
+          <a:fontRef idx="minor">
+            <a:schemeClr val="lt1"/>
+          </a:fontRef>
+        </p:style>
+        <p:txBody>
+          <a:bodyPr rtlCol="0" anchor="ctr"/>
+          <a:lstStyle/>
+          <a:p>
+            <a:pPr algn="ctr"/>
+          </a:p>
+        </p:txBody>
+      </p:sp>
+      <p:sp>
+        <p:nvSpPr>
+          <p:cNvPr id="14" name="Rectangle 13"/>
+          <p:cNvSpPr/>
+          <p:nvPr/>
+        </p:nvSpPr>
+        <p:spPr>
+          <a:xfrm>
+            <a:off x="4123944" y="3337560"/>
+            <a:ext cx="704088" cy="256032"/>
+          </a:xfrm>
+          <a:prstGeom prst="rect">
+            <a:avLst/>
+          </a:prstGeom>
+          <a:noFill/>
+          <a:ln>
+            <a:noFill/>
+          </a:ln>
+          <a:effectLst/>
+        </p:spPr>
+        <p:style>
+          <a:lnRef idx="1">
+            <a:schemeClr val="accent1"/>
+          </a:lnRef>
+          <a:fillRef idx="3">
+            <a:schemeClr val="accent1"/>
+          </a:fillRef>
+          <a:effectRef idx="2">
+            <a:schemeClr val="accent1"/>
+          </a:effectRef>
+          <a:fontRef idx="minor">
+            <a:schemeClr val="lt1"/>
+          </a:fontRef>
+        </p:style>
+        <p:txBody>
+          <a:bodyPr rtlCol="0" anchor="ctr" wrap="none" lIns="0" rIns="0" tIns="0" bIns="0"/>
+          <a:lstStyle/>
+          <a:p>
+            <a:pPr algn="l"/>
+            <a:r>
+              <a:rPr sz="900" b="1">
+                <a:solidFill>
+                  <a:srgbClr val="FFFFFF"/>
+                </a:solidFill>
+                <a:latin typeface="Trebuchet MS"/>
+              </a:rPr>
+              <a:t>DR V̂</a:t>
+            </a:r>
+          </a:p>
+        </p:txBody>
+      </p:sp>
+      <p:sp>
+        <p:nvSpPr>
+          <p:cNvPr id="15" name="Rectangle 14"/>
+          <p:cNvSpPr/>
+          <p:nvPr/>
+        </p:nvSpPr>
+        <p:spPr>
+          <a:xfrm>
+            <a:off x="4864607" y="3337560"/>
+            <a:ext cx="1600200" cy="256032"/>
+          </a:xfrm>
+          <a:prstGeom prst="rect">
+            <a:avLst/>
+          </a:prstGeom>
+          <a:solidFill>
+            <a:srgbClr val="0D1B2A"/>
+          </a:solidFill>
+          <a:ln w="12700">
+            <a:solidFill>
+              <a:srgbClr val="0D1B2A"/>
+            </a:solidFill>
+          </a:ln>
+          <a:effectLst/>
+        </p:spPr>
+        <p:style>
+          <a:lnRef idx="1">
+            <a:schemeClr val="accent1"/>
+          </a:lnRef>
+          <a:fillRef idx="3">
+            <a:schemeClr val="accent1"/>
+          </a:fillRef>
+          <a:effectRef idx="2">
+            <a:schemeClr val="accent1"/>
+          </a:effectRef>
+          <a:fontRef idx="minor">
+            <a:schemeClr val="lt1"/>
+          </a:fontRef>
+        </p:style>
+        <p:txBody>
+          <a:bodyPr rtlCol="0" anchor="ctr"/>
+          <a:lstStyle/>
+          <a:p>
+            <a:pPr algn="ctr"/>
+          </a:p>
+        </p:txBody>
+      </p:sp>
+      <p:sp>
+        <p:nvSpPr>
+          <p:cNvPr id="16" name="Rectangle 15"/>
+          <p:cNvSpPr/>
+          <p:nvPr/>
+        </p:nvSpPr>
+        <p:spPr>
+          <a:xfrm>
+            <a:off x="4901183" y="3337560"/>
+            <a:ext cx="1527048" cy="256032"/>
+          </a:xfrm>
+          <a:prstGeom prst="rect">
+            <a:avLst/>
+          </a:prstGeom>
+          <a:noFill/>
+          <a:ln>
+            <a:noFill/>
+          </a:ln>
+          <a:effectLst/>
+        </p:spPr>
+        <p:style>
+          <a:lnRef idx="1">
+            <a:schemeClr val="accent1"/>
+          </a:lnRef>
+          <a:fillRef idx="3">
+            <a:schemeClr val="accent1"/>
+          </a:fillRef>
+          <a:effectRef idx="2">
+            <a:schemeClr val="accent1"/>
+          </a:effectRef>
+          <a:fontRef idx="minor">
+            <a:schemeClr val="lt1"/>
+          </a:fontRef>
+        </p:style>
+        <p:txBody>
+          <a:bodyPr rtlCol="0" anchor="ctr" wrap="none" lIns="0" rIns="0" tIns="0" bIns="0"/>
+          <a:lstStyle/>
+          <a:p>
+            <a:pPr algn="l"/>
+            <a:r>
+              <a:rPr sz="900" b="1">
+                <a:solidFill>
+                  <a:srgbClr val="FFFFFF"/>
+                </a:solidFill>
+                <a:latin typeface="Trebuchet MS"/>
+              </a:rPr>
+              <a:t>DR 95% CI</a:t>
+            </a:r>
+          </a:p>
+        </p:txBody>
+      </p:sp>
+      <p:sp>
+        <p:nvSpPr>
+          <p:cNvPr id="17" name="Rectangle 16"/>
+          <p:cNvSpPr/>
+          <p:nvPr/>
+        </p:nvSpPr>
+        <p:spPr>
+          <a:xfrm>
+            <a:off x="6464807" y="3337560"/>
+            <a:ext cx="1234440" cy="256032"/>
+          </a:xfrm>
+          <a:prstGeom prst="rect">
+            <a:avLst/>
+          </a:prstGeom>
+          <a:solidFill>
+            <a:srgbClr val="0D1B2A"/>
+          </a:solidFill>
+          <a:ln w="12700">
+            <a:solidFill>
+              <a:srgbClr val="0D1B2A"/>
+            </a:solidFill>
+          </a:ln>
+          <a:effectLst/>
+        </p:spPr>
+        <p:style>
+          <a:lnRef idx="1">
+            <a:schemeClr val="accent1"/>
+          </a:lnRef>
+          <a:fillRef idx="3">
+            <a:schemeClr val="accent1"/>
+          </a:fillRef>
+          <a:effectRef idx="2">
+            <a:schemeClr val="accent1"/>
+          </a:effectRef>
+          <a:fontRef idx="minor">
+            <a:schemeClr val="lt1"/>
+          </a:fontRef>
+        </p:style>
+        <p:txBody>
+          <a:bodyPr rtlCol="0" anchor="ctr"/>
+          <a:lstStyle/>
+          <a:p>
+            <a:pPr algn="ctr"/>
+          </a:p>
+        </p:txBody>
+      </p:sp>
+      <p:sp>
+        <p:nvSpPr>
+          <p:cNvPr id="18" name="Rectangle 17"/>
+          <p:cNvSpPr/>
+          <p:nvPr/>
+        </p:nvSpPr>
+        <p:spPr>
+          <a:xfrm>
+            <a:off x="6501383" y="3337560"/>
+            <a:ext cx="1161288" cy="256032"/>
+          </a:xfrm>
+          <a:prstGeom prst="rect">
+            <a:avLst/>
+          </a:prstGeom>
+          <a:noFill/>
+          <a:ln>
+            <a:noFill/>
+          </a:ln>
+          <a:effectLst/>
+        </p:spPr>
+        <p:style>
+          <a:lnRef idx="1">
+            <a:schemeClr val="accent1"/>
+          </a:lnRef>
+          <a:fillRef idx="3">
+            <a:schemeClr val="accent1"/>
+          </a:fillRef>
+          <a:effectRef idx="2">
+            <a:schemeClr val="accent1"/>
+          </a:effectRef>
+          <a:fontRef idx="minor">
+            <a:schemeClr val="lt1"/>
+          </a:fontRef>
+        </p:style>
+        <p:txBody>
+          <a:bodyPr rtlCol="0" anchor="ctr" wrap="none" lIns="0" rIns="0" tIns="0" bIns="0"/>
+          <a:lstStyle/>
+          <a:p>
+            <a:pPr algn="l"/>
+            <a:r>
+              <a:rPr sz="900" b="1">
+                <a:solidFill>
+                  <a:srgbClr val="FFFFFF"/>
+                </a:solidFill>
+                <a:latin typeface="Trebuchet MS"/>
+              </a:rPr>
+              <a:t>naive∈CI?</a:t>
+            </a:r>
+          </a:p>
+        </p:txBody>
+      </p:sp>
+      <p:sp>
+        <p:nvSpPr>
+          <p:cNvPr id="19" name="Rectangle 18"/>
+          <p:cNvSpPr/>
+          <p:nvPr/>
+        </p:nvSpPr>
+        <p:spPr>
+          <a:xfrm>
+            <a:off x="7699248" y="3337560"/>
+            <a:ext cx="1243584" cy="256032"/>
+          </a:xfrm>
+          <a:prstGeom prst="rect">
+            <a:avLst/>
+          </a:prstGeom>
+          <a:solidFill>
+            <a:srgbClr val="0D1B2A"/>
+          </a:solidFill>
+          <a:ln w="12700">
+            <a:solidFill>
+              <a:srgbClr val="0D1B2A"/>
+            </a:solidFill>
+          </a:ln>
+          <a:effectLst/>
+        </p:spPr>
+        <p:style>
+          <a:lnRef idx="1">
+            <a:schemeClr val="accent1"/>
+          </a:lnRef>
+          <a:fillRef idx="3">
+            <a:schemeClr val="accent1"/>
+          </a:fillRef>
+          <a:effectRef idx="2">
+            <a:schemeClr val="accent1"/>
+          </a:effectRef>
+          <a:fontRef idx="minor">
+            <a:schemeClr val="lt1"/>
+          </a:fontRef>
+        </p:style>
+        <p:txBody>
+          <a:bodyPr rtlCol="0" anchor="ctr"/>
+          <a:lstStyle/>
+          <a:p>
+            <a:pPr algn="ctr"/>
+          </a:p>
+        </p:txBody>
+      </p:sp>
+      <p:sp>
+        <p:nvSpPr>
+          <p:cNvPr id="20" name="Rectangle 19"/>
+          <p:cNvSpPr/>
+          <p:nvPr/>
+        </p:nvSpPr>
+        <p:spPr>
+          <a:xfrm>
+            <a:off x="7735823" y="3337560"/>
+            <a:ext cx="1170432" cy="256032"/>
+          </a:xfrm>
+          <a:prstGeom prst="rect">
+            <a:avLst/>
+          </a:prstGeom>
+          <a:noFill/>
+          <a:ln>
+            <a:noFill/>
+          </a:ln>
+          <a:effectLst/>
+        </p:spPr>
+        <p:style>
+          <a:lnRef idx="1">
+            <a:schemeClr val="accent1"/>
+          </a:lnRef>
+          <a:fillRef idx="3">
+            <a:schemeClr val="accent1"/>
+          </a:fillRef>
+          <a:effectRef idx="2">
+            <a:schemeClr val="accent1"/>
+          </a:effectRef>
+          <a:fontRef idx="minor">
+            <a:schemeClr val="lt1"/>
+          </a:fontRef>
+        </p:style>
+        <p:txBody>
+          <a:bodyPr rtlCol="0" anchor="ctr" wrap="none" lIns="0" rIns="0" tIns="0" bIns="0"/>
+          <a:lstStyle/>
+          <a:p>
+            <a:pPr algn="l"/>
+            <a:r>
+              <a:rPr sz="900" b="1">
+                <a:solidFill>
+                  <a:srgbClr val="FFFFFF"/>
+                </a:solidFill>
+                <a:latin typeface="Trebuchet MS"/>
+              </a:rPr>
+              <a:t>V*∈CI?</a:t>
+            </a:r>
+          </a:p>
+        </p:txBody>
+      </p:sp>
+      <p:sp>
+        <p:nvSpPr>
+          <p:cNvPr id="21" name="Rectangle 20"/>
+          <p:cNvSpPr/>
+          <p:nvPr/>
+        </p:nvSpPr>
+        <p:spPr>
+          <a:xfrm>
+            <a:off x="201168" y="3593591"/>
+            <a:ext cx="2331720" cy="241401"/>
+          </a:xfrm>
+          <a:prstGeom prst="rect">
+            <a:avLst/>
+          </a:prstGeom>
+          <a:solidFill>
+            <a:srgbClr val="FFFFFF"/>
+          </a:solidFill>
+          <a:ln w="12700">
+            <a:solidFill>
+              <a:srgbClr val="D8E6EA"/>
+            </a:solidFill>
+          </a:ln>
+          <a:effectLst/>
+        </p:spPr>
+        <p:style>
+          <a:lnRef idx="1">
+            <a:schemeClr val="accent1"/>
+          </a:lnRef>
+          <a:fillRef idx="3">
+            <a:schemeClr val="accent1"/>
+          </a:fillRef>
+          <a:effectRef idx="2">
+            <a:schemeClr val="accent1"/>
+          </a:effectRef>
+          <a:fontRef idx="minor">
+            <a:schemeClr val="lt1"/>
+          </a:fontRef>
+        </p:style>
+        <p:txBody>
+          <a:bodyPr rtlCol="0" anchor="ctr"/>
+          <a:lstStyle/>
+          <a:p>
+            <a:pPr algn="ctr"/>
+          </a:p>
+        </p:txBody>
+      </p:sp>
+      <p:sp>
+        <p:nvSpPr>
+          <p:cNvPr id="22" name="Rectangle 21"/>
+          <p:cNvSpPr/>
+          <p:nvPr/>
+        </p:nvSpPr>
+        <p:spPr>
+          <a:xfrm>
+            <a:off x="246888" y="3593591"/>
+            <a:ext cx="2240279" cy="241401"/>
+          </a:xfrm>
+          <a:prstGeom prst="rect">
+            <a:avLst/>
+          </a:prstGeom>
+          <a:noFill/>
+          <a:ln>
+            <a:noFill/>
+          </a:ln>
+          <a:effectLst/>
+        </p:spPr>
+        <p:style>
+          <a:lnRef idx="1">
+            <a:schemeClr val="accent1"/>
+          </a:lnRef>
+          <a:fillRef idx="3">
+            <a:schemeClr val="accent1"/>
+          </a:fillRef>
+          <a:effectRef idx="2">
+            <a:schemeClr val="accent1"/>
+          </a:effectRef>
+          <a:fontRef idx="minor">
+            <a:schemeClr val="lt1"/>
+          </a:fontRef>
+        </p:style>
+        <p:txBody>
+          <a:bodyPr rtlCol="0" anchor="ctr" wrap="none" lIns="0" rIns="0" tIns="0" bIns="0"/>
+          <a:lstStyle/>
+          <a:p>
+            <a:pPr algn="l"/>
+            <a:r>
+              <a:rPr sz="900" b="1">
+                <a:solidFill>
+                  <a:srgbClr val="1A2B35"/>
+                </a:solidFill>
+                <a:latin typeface="Trebuchet MS"/>
+              </a:rPr>
+              <a:t>A. Dobry overlap, Δ=0</a:t>
+            </a:r>
+          </a:p>
+        </p:txBody>
+      </p:sp>
+      <p:sp>
+        <p:nvSpPr>
+          <p:cNvPr id="23" name="Rectangle 22"/>
+          <p:cNvSpPr/>
+          <p:nvPr/>
+        </p:nvSpPr>
+        <p:spPr>
+          <a:xfrm>
+            <a:off x="2532888" y="3593591"/>
+            <a:ext cx="594360" cy="241401"/>
+          </a:xfrm>
+          <a:prstGeom prst="rect">
+            <a:avLst/>
+          </a:prstGeom>
+          <a:solidFill>
+            <a:srgbClr val="FFFFFF"/>
+          </a:solidFill>
+          <a:ln w="12700">
+            <a:solidFill>
+              <a:srgbClr val="D8E6EA"/>
+            </a:solidFill>
+          </a:ln>
+          <a:effectLst/>
+        </p:spPr>
+        <p:style>
+          <a:lnRef idx="1">
+            <a:schemeClr val="accent1"/>
+          </a:lnRef>
+          <a:fillRef idx="3">
+            <a:schemeClr val="accent1"/>
+          </a:fillRef>
+          <a:effectRef idx="2">
+            <a:schemeClr val="accent1"/>
+          </a:effectRef>
+          <a:fontRef idx="minor">
+            <a:schemeClr val="lt1"/>
+          </a:fontRef>
+        </p:style>
+        <p:txBody>
+          <a:bodyPr rtlCol="0" anchor="ctr"/>
+          <a:lstStyle/>
+          <a:p>
+            <a:pPr algn="ctr"/>
+          </a:p>
+        </p:txBody>
+      </p:sp>
+      <p:sp>
+        <p:nvSpPr>
+          <p:cNvPr id="24" name="Rectangle 23"/>
+          <p:cNvSpPr/>
+          <p:nvPr/>
+        </p:nvSpPr>
+        <p:spPr>
+          <a:xfrm>
+            <a:off x="2578608" y="3593591"/>
+            <a:ext cx="502920" cy="241401"/>
+          </a:xfrm>
+          <a:prstGeom prst="rect">
+            <a:avLst/>
+          </a:prstGeom>
+          <a:noFill/>
+          <a:ln>
+            <a:noFill/>
+          </a:ln>
+          <a:effectLst/>
+        </p:spPr>
+        <p:style>
+          <a:lnRef idx="1">
+            <a:schemeClr val="accent1"/>
+          </a:lnRef>
+          <a:fillRef idx="3">
+            <a:schemeClr val="accent1"/>
+          </a:fillRef>
+          <a:effectRef idx="2">
+            <a:schemeClr val="accent1"/>
+          </a:effectRef>
+          <a:fontRef idx="minor">
+            <a:schemeClr val="lt1"/>
+          </a:fontRef>
+        </p:style>
+        <p:txBody>
+          <a:bodyPr rtlCol="0" anchor="ctr" wrap="none" lIns="0" rIns="0" tIns="0" bIns="0"/>
+          <a:lstStyle/>
+          <a:p>
+            <a:pPr algn="ctr"/>
+            <a:r>
+              <a:rPr sz="900" b="0">
+                <a:solidFill>
+                  <a:srgbClr val="1A2B35"/>
+                </a:solidFill>
+                <a:latin typeface="Consolas"/>
+              </a:rPr>
+              <a:t>0.926</a:t>
+            </a:r>
+          </a:p>
+        </p:txBody>
+      </p:sp>
+      <p:sp>
+        <p:nvSpPr>
+          <p:cNvPr id="25" name="Rectangle 24"/>
+          <p:cNvSpPr/>
+          <p:nvPr/>
+        </p:nvSpPr>
+        <p:spPr>
+          <a:xfrm>
+            <a:off x="3127248" y="3593591"/>
+            <a:ext cx="960120" cy="241401"/>
+          </a:xfrm>
+          <a:prstGeom prst="rect">
+            <a:avLst/>
+          </a:prstGeom>
+          <a:solidFill>
+            <a:srgbClr val="FFFFFF"/>
+          </a:solidFill>
+          <a:ln w="12700">
+            <a:solidFill>
+              <a:srgbClr val="D8E6EA"/>
+            </a:solidFill>
+          </a:ln>
+          <a:effectLst/>
+        </p:spPr>
+        <p:style>
+          <a:lnRef idx="1">
+            <a:schemeClr val="accent1"/>
+          </a:lnRef>
+          <a:fillRef idx="3">
+            <a:schemeClr val="accent1"/>
+          </a:fillRef>
+          <a:effectRef idx="2">
+            <a:schemeClr val="accent1"/>
+          </a:effectRef>
+          <a:fontRef idx="minor">
+            <a:schemeClr val="lt1"/>
+          </a:fontRef>
+        </p:style>
+        <p:txBody>
+          <a:bodyPr rtlCol="0" anchor="ctr"/>
+          <a:lstStyle/>
+          <a:p>
+            <a:pPr algn="ctr"/>
+          </a:p>
+        </p:txBody>
+      </p:sp>
+      <p:sp>
+        <p:nvSpPr>
+          <p:cNvPr id="26" name="Rectangle 25"/>
+          <p:cNvSpPr/>
+          <p:nvPr/>
+        </p:nvSpPr>
+        <p:spPr>
+          <a:xfrm>
+            <a:off x="3172968" y="3593591"/>
+            <a:ext cx="868680" cy="241401"/>
+          </a:xfrm>
+          <a:prstGeom prst="rect">
+            <a:avLst/>
+          </a:prstGeom>
+          <a:noFill/>
+          <a:ln>
+            <a:noFill/>
+          </a:ln>
+          <a:effectLst/>
+        </p:spPr>
+        <p:style>
+          <a:lnRef idx="1">
+            <a:schemeClr val="accent1"/>
+          </a:lnRef>
+          <a:fillRef idx="3">
+            <a:schemeClr val="accent1"/>
+          </a:fillRef>
+          <a:effectRef idx="2">
+            <a:schemeClr val="accent1"/>
+          </a:effectRef>
+          <a:fontRef idx="minor">
+            <a:schemeClr val="lt1"/>
+          </a:fontRef>
+        </p:style>
+        <p:txBody>
+          <a:bodyPr rtlCol="0" anchor="ctr" wrap="none" lIns="0" rIns="0" tIns="0" bIns="0"/>
+          <a:lstStyle/>
+          <a:p>
+            <a:pPr algn="ctr"/>
+            <a:r>
+              <a:rPr sz="900" b="0">
+                <a:solidFill>
+                  <a:srgbClr val="1A2B35"/>
+                </a:solidFill>
+                <a:latin typeface="Consolas"/>
+              </a:rPr>
+              <a:t>0.0000</a:t>
+            </a:r>
+          </a:p>
+        </p:txBody>
+      </p:sp>
+      <p:sp>
+        <p:nvSpPr>
+          <p:cNvPr id="27" name="Rectangle 26"/>
+          <p:cNvSpPr/>
+          <p:nvPr/>
+        </p:nvSpPr>
+        <p:spPr>
+          <a:xfrm>
+            <a:off x="4087368" y="3593591"/>
+            <a:ext cx="777240" cy="241401"/>
+          </a:xfrm>
+          <a:prstGeom prst="rect">
+            <a:avLst/>
+          </a:prstGeom>
+          <a:solidFill>
+            <a:srgbClr val="FFFFFF"/>
+          </a:solidFill>
+          <a:ln w="12700">
+            <a:solidFill>
+              <a:srgbClr val="D8E6EA"/>
+            </a:solidFill>
+          </a:ln>
+          <a:effectLst/>
+        </p:spPr>
+        <p:style>
+          <a:lnRef idx="1">
+            <a:schemeClr val="accent1"/>
+          </a:lnRef>
+          <a:fillRef idx="3">
+            <a:schemeClr val="accent1"/>
+          </a:fillRef>
+          <a:effectRef idx="2">
+            <a:schemeClr val="accent1"/>
+          </a:effectRef>
+          <a:fontRef idx="minor">
+            <a:schemeClr val="lt1"/>
+          </a:fontRef>
+        </p:style>
+        <p:txBody>
+          <a:bodyPr rtlCol="0" anchor="ctr"/>
+          <a:lstStyle/>
+          <a:p>
+            <a:pPr algn="ctr"/>
+          </a:p>
+        </p:txBody>
+      </p:sp>
+      <p:sp>
+        <p:nvSpPr>
+          <p:cNvPr id="28" name="Rectangle 27"/>
+          <p:cNvSpPr/>
+          <p:nvPr/>
+        </p:nvSpPr>
+        <p:spPr>
+          <a:xfrm>
+            <a:off x="4133087" y="3593591"/>
+            <a:ext cx="685800" cy="241401"/>
+          </a:xfrm>
+          <a:prstGeom prst="rect">
+            <a:avLst/>
+          </a:prstGeom>
+          <a:noFill/>
+          <a:ln>
+            <a:noFill/>
+          </a:ln>
+          <a:effectLst/>
+        </p:spPr>
+        <p:style>
+          <a:lnRef idx="1">
+            <a:schemeClr val="accent1"/>
+          </a:lnRef>
+          <a:fillRef idx="3">
+            <a:schemeClr val="accent1"/>
+          </a:fillRef>
+          <a:effectRef idx="2">
+            <a:schemeClr val="accent1"/>
+          </a:effectRef>
+          <a:fontRef idx="minor">
+            <a:schemeClr val="lt1"/>
+          </a:fontRef>
+        </p:style>
+        <p:txBody>
+          <a:bodyPr rtlCol="0" anchor="ctr" wrap="none" lIns="0" rIns="0" tIns="0" bIns="0"/>
+          <a:lstStyle/>
+          <a:p>
+            <a:pPr algn="ctr"/>
+            <a:r>
+              <a:rPr sz="900" b="1">
+                <a:solidFill>
+                  <a:srgbClr val="7C60D4"/>
+                </a:solidFill>
+                <a:latin typeface="Trebuchet MS"/>
+              </a:rPr>
+              <a:t>0.02155</a:t>
+            </a:r>
+          </a:p>
+        </p:txBody>
+      </p:sp>
+      <p:sp>
+        <p:nvSpPr>
+          <p:cNvPr id="29" name="Rectangle 28"/>
+          <p:cNvSpPr/>
+          <p:nvPr/>
+        </p:nvSpPr>
+        <p:spPr>
+          <a:xfrm>
+            <a:off x="4864607" y="3593591"/>
+            <a:ext cx="1600200" cy="241401"/>
+          </a:xfrm>
+          <a:prstGeom prst="rect">
+            <a:avLst/>
+          </a:prstGeom>
+          <a:solidFill>
+            <a:srgbClr val="FFFFFF"/>
+          </a:solidFill>
+          <a:ln w="12700">
+            <a:solidFill>
+              <a:srgbClr val="D8E6EA"/>
+            </a:solidFill>
+          </a:ln>
+          <a:effectLst/>
+        </p:spPr>
+        <p:style>
+          <a:lnRef idx="1">
+            <a:schemeClr val="accent1"/>
+          </a:lnRef>
+          <a:fillRef idx="3">
+            <a:schemeClr val="accent1"/>
+          </a:fillRef>
+          <a:effectRef idx="2">
+            <a:schemeClr val="accent1"/>
+          </a:effectRef>
+          <a:fontRef idx="minor">
+            <a:schemeClr val="lt1"/>
+          </a:fontRef>
+        </p:style>
+        <p:txBody>
+          <a:bodyPr rtlCol="0" anchor="ctr"/>
+          <a:lstStyle/>
+          <a:p>
+            <a:pPr algn="ctr"/>
+          </a:p>
+        </p:txBody>
+      </p:sp>
+      <p:sp>
+        <p:nvSpPr>
+          <p:cNvPr id="30" name="Rectangle 29"/>
+          <p:cNvSpPr/>
+          <p:nvPr/>
+        </p:nvSpPr>
+        <p:spPr>
+          <a:xfrm>
+            <a:off x="4910327" y="3593591"/>
+            <a:ext cx="1508760" cy="241401"/>
+          </a:xfrm>
+          <a:prstGeom prst="rect">
+            <a:avLst/>
+          </a:prstGeom>
+          <a:noFill/>
+          <a:ln>
+            <a:noFill/>
+          </a:ln>
+          <a:effectLst/>
+        </p:spPr>
+        <p:style>
+          <a:lnRef idx="1">
+            <a:schemeClr val="accent1"/>
+          </a:lnRef>
+          <a:fillRef idx="3">
+            <a:schemeClr val="accent1"/>
+          </a:fillRef>
+          <a:effectRef idx="2">
+            <a:schemeClr val="accent1"/>
+          </a:effectRef>
+          <a:fontRef idx="minor">
+            <a:schemeClr val="lt1"/>
+          </a:fontRef>
+        </p:style>
+        <p:txBody>
+          <a:bodyPr rtlCol="0" anchor="ctr" wrap="none" lIns="0" rIns="0" tIns="0" bIns="0"/>
+          <a:lstStyle/>
+          <a:p>
+            <a:pPr algn="ctr"/>
+            <a:r>
+              <a:rPr sz="850" b="0">
+                <a:solidFill>
+                  <a:srgbClr val="1A2B35"/>
+                </a:solidFill>
+                <a:latin typeface="Consolas"/>
+              </a:rPr>
+              <a:t>[0.0196, 0.0239]</a:t>
+            </a:r>
+          </a:p>
+        </p:txBody>
+      </p:sp>
+      <p:sp>
+        <p:nvSpPr>
+          <p:cNvPr id="31" name="Rectangle 30"/>
+          <p:cNvSpPr/>
+          <p:nvPr/>
+        </p:nvSpPr>
+        <p:spPr>
+          <a:xfrm>
+            <a:off x="6464807" y="3593591"/>
+            <a:ext cx="1234440" cy="241401"/>
+          </a:xfrm>
+          <a:prstGeom prst="rect">
+            <a:avLst/>
+          </a:prstGeom>
+          <a:solidFill>
+            <a:srgbClr val="FFFFFF"/>
+          </a:solidFill>
+          <a:ln w="12700">
+            <a:solidFill>
+              <a:srgbClr val="D8E6EA"/>
+            </a:solidFill>
+          </a:ln>
+          <a:effectLst/>
+        </p:spPr>
+        <p:style>
+          <a:lnRef idx="1">
+            <a:schemeClr val="accent1"/>
+          </a:lnRef>
+          <a:fillRef idx="3">
+            <a:schemeClr val="accent1"/>
+          </a:fillRef>
+          <a:effectRef idx="2">
+            <a:schemeClr val="accent1"/>
+          </a:effectRef>
+          <a:fontRef idx="minor">
+            <a:schemeClr val="lt1"/>
+          </a:fontRef>
+        </p:style>
+        <p:txBody>
+          <a:bodyPr rtlCol="0" anchor="ctr"/>
+          <a:lstStyle/>
+          <a:p>
+            <a:pPr algn="ctr"/>
+          </a:p>
+        </p:txBody>
+      </p:sp>
+      <p:sp>
+        <p:nvSpPr>
+          <p:cNvPr id="32" name="Rectangle 31"/>
+          <p:cNvSpPr/>
+          <p:nvPr/>
+        </p:nvSpPr>
+        <p:spPr>
+          <a:xfrm>
+            <a:off x="6510527" y="3593591"/>
+            <a:ext cx="1143000" cy="241401"/>
+          </a:xfrm>
+          <a:prstGeom prst="rect">
+            <a:avLst/>
+          </a:prstGeom>
+          <a:noFill/>
+          <a:ln>
+            <a:noFill/>
+          </a:ln>
+          <a:effectLst/>
+        </p:spPr>
+        <p:style>
+          <a:lnRef idx="1">
+            <a:schemeClr val="accent1"/>
+          </a:lnRef>
+          <a:fillRef idx="3">
+            <a:schemeClr val="accent1"/>
+          </a:fillRef>
+          <a:effectRef idx="2">
+            <a:schemeClr val="accent1"/>
+          </a:effectRef>
+          <a:fontRef idx="minor">
+            <a:schemeClr val="lt1"/>
+          </a:fontRef>
+        </p:style>
+        <p:txBody>
+          <a:bodyPr rtlCol="0" anchor="ctr" wrap="none" lIns="0" rIns="0" tIns="0" bIns="0"/>
+          <a:lstStyle/>
+          <a:p>
+            <a:pPr algn="ctr"/>
+            <a:r>
+              <a:rPr sz="900" b="1">
+                <a:solidFill>
+                  <a:srgbClr val="2D9E4F"/>
+                </a:solidFill>
+                <a:latin typeface="Trebuchet MS"/>
+              </a:rPr>
+              <a:t>tak</a:t>
+            </a:r>
+          </a:p>
+        </p:txBody>
+      </p:sp>
+      <p:sp>
+        <p:nvSpPr>
+          <p:cNvPr id="33" name="Rectangle 32"/>
+          <p:cNvSpPr/>
+          <p:nvPr/>
+        </p:nvSpPr>
+        <p:spPr>
+          <a:xfrm>
+            <a:off x="7699248" y="3593591"/>
+            <a:ext cx="1243584" cy="241401"/>
+          </a:xfrm>
+          <a:prstGeom prst="rect">
+            <a:avLst/>
+          </a:prstGeom>
+          <a:solidFill>
+            <a:srgbClr val="FFFFFF"/>
+          </a:solidFill>
+          <a:ln w="12700">
+            <a:solidFill>
+              <a:srgbClr val="D8E6EA"/>
+            </a:solidFill>
+          </a:ln>
+          <a:effectLst/>
+        </p:spPr>
+        <p:style>
+          <a:lnRef idx="1">
+            <a:schemeClr val="accent1"/>
+          </a:lnRef>
+          <a:fillRef idx="3">
+            <a:schemeClr val="accent1"/>
+          </a:fillRef>
+          <a:effectRef idx="2">
+            <a:schemeClr val="accent1"/>
+          </a:effectRef>
+          <a:fontRef idx="minor">
+            <a:schemeClr val="lt1"/>
+          </a:fontRef>
+        </p:style>
+        <p:txBody>
+          <a:bodyPr rtlCol="0" anchor="ctr"/>
+          <a:lstStyle/>
+          <a:p>
+            <a:pPr algn="ctr"/>
+          </a:p>
+        </p:txBody>
+      </p:sp>
+      <p:sp>
+        <p:nvSpPr>
+          <p:cNvPr id="34" name="Rectangle 33"/>
+          <p:cNvSpPr/>
+          <p:nvPr/>
+        </p:nvSpPr>
+        <p:spPr>
+          <a:xfrm>
+            <a:off x="7744968" y="3593591"/>
+            <a:ext cx="1152144" cy="241401"/>
+          </a:xfrm>
+          <a:prstGeom prst="rect">
+            <a:avLst/>
+          </a:prstGeom>
+          <a:noFill/>
+          <a:ln>
+            <a:noFill/>
+          </a:ln>
+          <a:effectLst/>
+        </p:spPr>
+        <p:style>
+          <a:lnRef idx="1">
+            <a:schemeClr val="accent1"/>
+          </a:lnRef>
+          <a:fillRef idx="3">
+            <a:schemeClr val="accent1"/>
+          </a:fillRef>
+          <a:effectRef idx="2">
+            <a:schemeClr val="accent1"/>
+          </a:effectRef>
+          <a:fontRef idx="minor">
+            <a:schemeClr val="lt1"/>
+          </a:fontRef>
+        </p:style>
+        <p:txBody>
+          <a:bodyPr rtlCol="0" anchor="ctr" wrap="none" lIns="0" rIns="0" tIns="0" bIns="0"/>
+          <a:lstStyle/>
+          <a:p>
+            <a:pPr algn="ctr"/>
+            <a:r>
+              <a:rPr sz="900" b="1">
+                <a:solidFill>
+                  <a:srgbClr val="2D9E4F"/>
+                </a:solidFill>
+                <a:latin typeface="Trebuchet MS"/>
+              </a:rPr>
+              <a:t>tak</a:t>
+            </a:r>
+          </a:p>
+        </p:txBody>
+      </p:sp>
+      <p:sp>
+        <p:nvSpPr>
+          <p:cNvPr id="35" name="Rectangle 34"/>
+          <p:cNvSpPr/>
+          <p:nvPr/>
+        </p:nvSpPr>
+        <p:spPr>
+          <a:xfrm>
+            <a:off x="201168" y="3834993"/>
+            <a:ext cx="2331720" cy="241401"/>
+          </a:xfrm>
+          <a:prstGeom prst="rect">
+            <a:avLst/>
+          </a:prstGeom>
+          <a:solidFill>
+            <a:srgbClr val="F4F7F8"/>
+          </a:solidFill>
+          <a:ln w="12700">
+            <a:solidFill>
+              <a:srgbClr val="D8E6EA"/>
+            </a:solidFill>
+          </a:ln>
+          <a:effectLst/>
+        </p:spPr>
+        <p:style>
+          <a:lnRef idx="1">
+            <a:schemeClr val="accent1"/>
+          </a:lnRef>
+          <a:fillRef idx="3">
+            <a:schemeClr val="accent1"/>
+          </a:fillRef>
+          <a:effectRef idx="2">
+            <a:schemeClr val="accent1"/>
+          </a:effectRef>
+          <a:fontRef idx="minor">
+            <a:schemeClr val="lt1"/>
+          </a:fontRef>
+        </p:style>
+        <p:txBody>
+          <a:bodyPr rtlCol="0" anchor="ctr"/>
+          <a:lstStyle/>
+          <a:p>
+            <a:pPr algn="ctr"/>
+          </a:p>
+        </p:txBody>
+      </p:sp>
+      <p:sp>
+        <p:nvSpPr>
+          <p:cNvPr id="36" name="Rectangle 35"/>
+          <p:cNvSpPr/>
+          <p:nvPr/>
+        </p:nvSpPr>
+        <p:spPr>
+          <a:xfrm>
+            <a:off x="246888" y="3834993"/>
+            <a:ext cx="2240279" cy="241401"/>
+          </a:xfrm>
+          <a:prstGeom prst="rect">
+            <a:avLst/>
+          </a:prstGeom>
+          <a:noFill/>
+          <a:ln>
+            <a:noFill/>
+          </a:ln>
+          <a:effectLst/>
+        </p:spPr>
+        <p:style>
+          <a:lnRef idx="1">
+            <a:schemeClr val="accent1"/>
+          </a:lnRef>
+          <a:fillRef idx="3">
+            <a:schemeClr val="accent1"/>
+          </a:fillRef>
+          <a:effectRef idx="2">
+            <a:schemeClr val="accent1"/>
+          </a:effectRef>
+          <a:fontRef idx="minor">
+            <a:schemeClr val="lt1"/>
+          </a:fontRef>
+        </p:style>
+        <p:txBody>
+          <a:bodyPr rtlCol="0" anchor="ctr" wrap="none" lIns="0" rIns="0" tIns="0" bIns="0"/>
+          <a:lstStyle/>
+          <a:p>
+            <a:pPr algn="l"/>
+            <a:r>
+              <a:rPr sz="900" b="1">
+                <a:solidFill>
+                  <a:srgbClr val="1A2B35"/>
+                </a:solidFill>
+                <a:latin typeface="Trebuchet MS"/>
+              </a:rPr>
+              <a:t>B. Dobry overlap, Δ=duży</a:t>
+            </a:r>
+          </a:p>
+        </p:txBody>
+      </p:sp>
+      <p:sp>
+        <p:nvSpPr>
+          <p:cNvPr id="37" name="Rectangle 36"/>
+          <p:cNvSpPr/>
+          <p:nvPr/>
+        </p:nvSpPr>
+        <p:spPr>
+          <a:xfrm>
+            <a:off x="2532888" y="3834993"/>
+            <a:ext cx="594360" cy="241401"/>
+          </a:xfrm>
+          <a:prstGeom prst="rect">
+            <a:avLst/>
+          </a:prstGeom>
+          <a:solidFill>
+            <a:srgbClr val="F4F7F8"/>
+          </a:solidFill>
+          <a:ln w="12700">
+            <a:solidFill>
+              <a:srgbClr val="D8E6EA"/>
+            </a:solidFill>
+          </a:ln>
+          <a:effectLst/>
+        </p:spPr>
+        <p:style>
+          <a:lnRef idx="1">
+            <a:schemeClr val="accent1"/>
+          </a:lnRef>
+          <a:fillRef idx="3">
+            <a:schemeClr val="accent1"/>
+          </a:fillRef>
+          <a:effectRef idx="2">
+            <a:schemeClr val="accent1"/>
+          </a:effectRef>
+          <a:fontRef idx="minor">
+            <a:schemeClr val="lt1"/>
+          </a:fontRef>
+        </p:style>
+        <p:txBody>
+          <a:bodyPr rtlCol="0" anchor="ctr"/>
+          <a:lstStyle/>
+          <a:p>
+            <a:pPr algn="ctr"/>
+          </a:p>
+        </p:txBody>
+      </p:sp>
+      <p:sp>
+        <p:nvSpPr>
+          <p:cNvPr id="38" name="Rectangle 37"/>
+          <p:cNvSpPr/>
+          <p:nvPr/>
+        </p:nvSpPr>
+        <p:spPr>
+          <a:xfrm>
+            <a:off x="2578608" y="3834993"/>
+            <a:ext cx="502920" cy="241401"/>
+          </a:xfrm>
+          <a:prstGeom prst="rect">
+            <a:avLst/>
+          </a:prstGeom>
+          <a:noFill/>
+          <a:ln>
+            <a:noFill/>
+          </a:ln>
+          <a:effectLst/>
+        </p:spPr>
+        <p:style>
+          <a:lnRef idx="1">
+            <a:schemeClr val="accent1"/>
+          </a:lnRef>
+          <a:fillRef idx="3">
+            <a:schemeClr val="accent1"/>
+          </a:fillRef>
+          <a:effectRef idx="2">
+            <a:schemeClr val="accent1"/>
+          </a:effectRef>
+          <a:fontRef idx="minor">
+            <a:schemeClr val="lt1"/>
+          </a:fontRef>
+        </p:style>
+        <p:txBody>
+          <a:bodyPr rtlCol="0" anchor="ctr" wrap="none" lIns="0" rIns="0" tIns="0" bIns="0"/>
+          <a:lstStyle/>
+          <a:p>
+            <a:pPr algn="ctr"/>
+            <a:r>
+              <a:rPr sz="900" b="0">
+                <a:solidFill>
+                  <a:srgbClr val="1A2B35"/>
+                </a:solidFill>
+                <a:latin typeface="Consolas"/>
+              </a:rPr>
+              <a:t>0.926</a:t>
+            </a:r>
+          </a:p>
+        </p:txBody>
+      </p:sp>
+      <p:sp>
+        <p:nvSpPr>
+          <p:cNvPr id="39" name="Rectangle 38"/>
+          <p:cNvSpPr/>
+          <p:nvPr/>
+        </p:nvSpPr>
+        <p:spPr>
+          <a:xfrm>
+            <a:off x="3127248" y="3834993"/>
+            <a:ext cx="960120" cy="241401"/>
+          </a:xfrm>
+          <a:prstGeom prst="rect">
+            <a:avLst/>
+          </a:prstGeom>
+          <a:solidFill>
+            <a:srgbClr val="F4F7F8"/>
+          </a:solidFill>
+          <a:ln w="12700">
+            <a:solidFill>
+              <a:srgbClr val="D8E6EA"/>
+            </a:solidFill>
+          </a:ln>
+          <a:effectLst/>
+        </p:spPr>
+        <p:style>
+          <a:lnRef idx="1">
+            <a:schemeClr val="accent1"/>
+          </a:lnRef>
+          <a:fillRef idx="3">
+            <a:schemeClr val="accent1"/>
+          </a:fillRef>
+          <a:effectRef idx="2">
+            <a:schemeClr val="accent1"/>
+          </a:effectRef>
+          <a:fontRef idx="minor">
+            <a:schemeClr val="lt1"/>
+          </a:fontRef>
+        </p:style>
+        <p:txBody>
+          <a:bodyPr rtlCol="0" anchor="ctr"/>
+          <a:lstStyle/>
+          <a:p>
+            <a:pPr algn="ctr"/>
+          </a:p>
+        </p:txBody>
+      </p:sp>
+      <p:sp>
+        <p:nvSpPr>
+          <p:cNvPr id="40" name="Rectangle 39"/>
+          <p:cNvSpPr/>
+          <p:nvPr/>
+        </p:nvSpPr>
+        <p:spPr>
+          <a:xfrm>
+            <a:off x="3172968" y="3834993"/>
+            <a:ext cx="868680" cy="241401"/>
+          </a:xfrm>
+          <a:prstGeom prst="rect">
+            <a:avLst/>
+          </a:prstGeom>
+          <a:noFill/>
+          <a:ln>
+            <a:noFill/>
+          </a:ln>
+          <a:effectLst/>
+        </p:spPr>
+        <p:style>
+          <a:lnRef idx="1">
+            <a:schemeClr val="accent1"/>
+          </a:lnRef>
+          <a:fillRef idx="3">
+            <a:schemeClr val="accent1"/>
+          </a:fillRef>
+          <a:effectRef idx="2">
+            <a:schemeClr val="accent1"/>
+          </a:effectRef>
+          <a:fontRef idx="minor">
+            <a:schemeClr val="lt1"/>
+          </a:fontRef>
+        </p:style>
+        <p:txBody>
+          <a:bodyPr rtlCol="0" anchor="ctr" wrap="none" lIns="0" rIns="0" tIns="0" bIns="0"/>
+          <a:lstStyle/>
+          <a:p>
+            <a:pPr algn="ctr"/>
+            <a:r>
+              <a:rPr sz="900" b="0">
+                <a:solidFill>
+                  <a:srgbClr val="1A2B35"/>
+                </a:solidFill>
+                <a:latin typeface="Consolas"/>
+              </a:rPr>
+              <a:t>+0.0121</a:t>
+            </a:r>
+          </a:p>
+        </p:txBody>
+      </p:sp>
+      <p:sp>
+        <p:nvSpPr>
+          <p:cNvPr id="41" name="Rectangle 40"/>
+          <p:cNvSpPr/>
+          <p:nvPr/>
+        </p:nvSpPr>
+        <p:spPr>
+          <a:xfrm>
+            <a:off x="4087368" y="3834993"/>
+            <a:ext cx="777240" cy="241401"/>
+          </a:xfrm>
+          <a:prstGeom prst="rect">
+            <a:avLst/>
+          </a:prstGeom>
+          <a:solidFill>
+            <a:srgbClr val="F4F7F8"/>
+          </a:solidFill>
+          <a:ln w="12700">
+            <a:solidFill>
+              <a:srgbClr val="D8E6EA"/>
+            </a:solidFill>
+          </a:ln>
+          <a:effectLst/>
+        </p:spPr>
+        <p:style>
+          <a:lnRef idx="1">
+            <a:schemeClr val="accent1"/>
+          </a:lnRef>
+          <a:fillRef idx="3">
+            <a:schemeClr val="accent1"/>
+          </a:fillRef>
+          <a:effectRef idx="2">
+            <a:schemeClr val="accent1"/>
+          </a:effectRef>
+          <a:fontRef idx="minor">
+            <a:schemeClr val="lt1"/>
+          </a:fontRef>
+        </p:style>
+        <p:txBody>
+          <a:bodyPr rtlCol="0" anchor="ctr"/>
+          <a:lstStyle/>
+          <a:p>
+            <a:pPr algn="ctr"/>
+          </a:p>
+        </p:txBody>
+      </p:sp>
+      <p:sp>
+        <p:nvSpPr>
+          <p:cNvPr id="42" name="Rectangle 41"/>
+          <p:cNvSpPr/>
+          <p:nvPr/>
+        </p:nvSpPr>
+        <p:spPr>
+          <a:xfrm>
+            <a:off x="4133087" y="3834993"/>
+            <a:ext cx="685800" cy="241401"/>
+          </a:xfrm>
+          <a:prstGeom prst="rect">
+            <a:avLst/>
+          </a:prstGeom>
+          <a:noFill/>
+          <a:ln>
+            <a:noFill/>
+          </a:ln>
+          <a:effectLst/>
+        </p:spPr>
+        <p:style>
+          <a:lnRef idx="1">
+            <a:schemeClr val="accent1"/>
+          </a:lnRef>
+          <a:fillRef idx="3">
+            <a:schemeClr val="accent1"/>
+          </a:fillRef>
+          <a:effectRef idx="2">
+            <a:schemeClr val="accent1"/>
+          </a:effectRef>
+          <a:fontRef idx="minor">
+            <a:schemeClr val="lt1"/>
+          </a:fontRef>
+        </p:style>
+        <p:txBody>
+          <a:bodyPr rtlCol="0" anchor="ctr" wrap="none" lIns="0" rIns="0" tIns="0" bIns="0"/>
+          <a:lstStyle/>
+          <a:p>
+            <a:pPr algn="ctr"/>
+            <a:r>
+              <a:rPr sz="900" b="1">
+                <a:solidFill>
+                  <a:srgbClr val="7C60D4"/>
+                </a:solidFill>
+                <a:latin typeface="Trebuchet MS"/>
+              </a:rPr>
+              <a:t>0.06744</a:t>
+            </a:r>
+          </a:p>
+        </p:txBody>
+      </p:sp>
+      <p:sp>
+        <p:nvSpPr>
+          <p:cNvPr id="43" name="Rectangle 42"/>
+          <p:cNvSpPr/>
+          <p:nvPr/>
+        </p:nvSpPr>
+        <p:spPr>
+          <a:xfrm>
+            <a:off x="4864607" y="3834993"/>
+            <a:ext cx="1600200" cy="241401"/>
+          </a:xfrm>
+          <a:prstGeom prst="rect">
+            <a:avLst/>
+          </a:prstGeom>
+          <a:solidFill>
+            <a:srgbClr val="F4F7F8"/>
+          </a:solidFill>
+          <a:ln w="12700">
+            <a:solidFill>
+              <a:srgbClr val="D8E6EA"/>
+            </a:solidFill>
+          </a:ln>
+          <a:effectLst/>
+        </p:spPr>
+        <p:style>
+          <a:lnRef idx="1">
+            <a:schemeClr val="accent1"/>
+          </a:lnRef>
+          <a:fillRef idx="3">
+            <a:schemeClr val="accent1"/>
+          </a:fillRef>
+          <a:effectRef idx="2">
+            <a:schemeClr val="accent1"/>
+          </a:effectRef>
+          <a:fontRef idx="minor">
+            <a:schemeClr val="lt1"/>
+          </a:fontRef>
+        </p:style>
+        <p:txBody>
+          <a:bodyPr rtlCol="0" anchor="ctr"/>
+          <a:lstStyle/>
+          <a:p>
+            <a:pPr algn="ctr"/>
+          </a:p>
+        </p:txBody>
+      </p:sp>
+      <p:sp>
+        <p:nvSpPr>
+          <p:cNvPr id="44" name="Rectangle 43"/>
+          <p:cNvSpPr/>
+          <p:nvPr/>
+        </p:nvSpPr>
+        <p:spPr>
+          <a:xfrm>
+            <a:off x="4910327" y="3834993"/>
+            <a:ext cx="1508760" cy="241401"/>
+          </a:xfrm>
+          <a:prstGeom prst="rect">
+            <a:avLst/>
+          </a:prstGeom>
+          <a:noFill/>
+          <a:ln>
+            <a:noFill/>
+          </a:ln>
+          <a:effectLst/>
+        </p:spPr>
+        <p:style>
+          <a:lnRef idx="1">
+            <a:schemeClr val="accent1"/>
+          </a:lnRef>
+          <a:fillRef idx="3">
+            <a:schemeClr val="accent1"/>
+          </a:fillRef>
+          <a:effectRef idx="2">
+            <a:schemeClr val="accent1"/>
+          </a:effectRef>
+          <a:fontRef idx="minor">
+            <a:schemeClr val="lt1"/>
+          </a:fontRef>
+        </p:style>
+        <p:txBody>
+          <a:bodyPr rtlCol="0" anchor="ctr" wrap="none" lIns="0" rIns="0" tIns="0" bIns="0"/>
+          <a:lstStyle/>
+          <a:p>
+            <a:pPr algn="ctr"/>
+            <a:r>
+              <a:rPr sz="850" b="0">
+                <a:solidFill>
+                  <a:srgbClr val="1A2B35"/>
+                </a:solidFill>
+                <a:latin typeface="Consolas"/>
+              </a:rPr>
+              <a:t>[0.0643, 0.0707]</a:t>
+            </a:r>
+          </a:p>
+        </p:txBody>
+      </p:sp>
+      <p:sp>
+        <p:nvSpPr>
+          <p:cNvPr id="45" name="Rectangle 44"/>
+          <p:cNvSpPr/>
+          <p:nvPr/>
+        </p:nvSpPr>
+        <p:spPr>
+          <a:xfrm>
+            <a:off x="6464807" y="3834993"/>
+            <a:ext cx="1234440" cy="241401"/>
+          </a:xfrm>
+          <a:prstGeom prst="rect">
+            <a:avLst/>
+          </a:prstGeom>
+          <a:solidFill>
+            <a:srgbClr val="F4F7F8"/>
+          </a:solidFill>
+          <a:ln w="12700">
+            <a:solidFill>
+              <a:srgbClr val="D8E6EA"/>
+            </a:solidFill>
+          </a:ln>
+          <a:effectLst/>
+        </p:spPr>
+        <p:style>
+          <a:lnRef idx="1">
+            <a:schemeClr val="accent1"/>
+          </a:lnRef>
+          <a:fillRef idx="3">
+            <a:schemeClr val="accent1"/>
+          </a:fillRef>
+          <a:effectRef idx="2">
+            <a:schemeClr val="accent1"/>
+          </a:effectRef>
+          <a:fontRef idx="minor">
+            <a:schemeClr val="lt1"/>
+          </a:fontRef>
+        </p:style>
+        <p:txBody>
+          <a:bodyPr rtlCol="0" anchor="ctr"/>
+          <a:lstStyle/>
+          <a:p>
+            <a:pPr algn="ctr"/>
+          </a:p>
+        </p:txBody>
+      </p:sp>
+      <p:sp>
+        <p:nvSpPr>
+          <p:cNvPr id="46" name="Rectangle 45"/>
+          <p:cNvSpPr/>
+          <p:nvPr/>
+        </p:nvSpPr>
+        <p:spPr>
+          <a:xfrm>
+            <a:off x="6510527" y="3834993"/>
+            <a:ext cx="1143000" cy="241401"/>
+          </a:xfrm>
+          <a:prstGeom prst="rect">
+            <a:avLst/>
+          </a:prstGeom>
+          <a:noFill/>
+          <a:ln>
+            <a:noFill/>
+          </a:ln>
+          <a:effectLst/>
+        </p:spPr>
+        <p:style>
+          <a:lnRef idx="1">
+            <a:schemeClr val="accent1"/>
+          </a:lnRef>
+          <a:fillRef idx="3">
+            <a:schemeClr val="accent1"/>
+          </a:fillRef>
+          <a:effectRef idx="2">
+            <a:schemeClr val="accent1"/>
+          </a:effectRef>
+          <a:fontRef idx="minor">
+            <a:schemeClr val="lt1"/>
+          </a:fontRef>
+        </p:style>
+        <p:txBody>
+          <a:bodyPr rtlCol="0" anchor="ctr" wrap="none" lIns="0" rIns="0" tIns="0" bIns="0"/>
+          <a:lstStyle/>
+          <a:p>
+            <a:pPr algn="ctr"/>
+            <a:r>
+              <a:rPr sz="900" b="1">
+                <a:solidFill>
+                  <a:srgbClr val="C0392B"/>
+                </a:solidFill>
+                <a:latin typeface="Trebuchet MS"/>
+              </a:rPr>
+              <a:t>nie</a:t>
+            </a:r>
+          </a:p>
+        </p:txBody>
+      </p:sp>
+      <p:sp>
+        <p:nvSpPr>
+          <p:cNvPr id="47" name="Rectangle 46"/>
+          <p:cNvSpPr/>
+          <p:nvPr/>
+        </p:nvSpPr>
+        <p:spPr>
+          <a:xfrm>
+            <a:off x="7699248" y="3834993"/>
+            <a:ext cx="1243584" cy="241401"/>
+          </a:xfrm>
+          <a:prstGeom prst="rect">
+            <a:avLst/>
+          </a:prstGeom>
+          <a:solidFill>
+            <a:srgbClr val="F4F7F8"/>
+          </a:solidFill>
+          <a:ln w="12700">
+            <a:solidFill>
+              <a:srgbClr val="D8E6EA"/>
+            </a:solidFill>
+          </a:ln>
+          <a:effectLst/>
+        </p:spPr>
+        <p:style>
+          <a:lnRef idx="1">
+            <a:schemeClr val="accent1"/>
+          </a:lnRef>
+          <a:fillRef idx="3">
+            <a:schemeClr val="accent1"/>
+          </a:fillRef>
+          <a:effectRef idx="2">
+            <a:schemeClr val="accent1"/>
+          </a:effectRef>
+          <a:fontRef idx="minor">
+            <a:schemeClr val="lt1"/>
+          </a:fontRef>
+        </p:style>
+        <p:txBody>
+          <a:bodyPr rtlCol="0" anchor="ctr"/>
+          <a:lstStyle/>
+          <a:p>
+            <a:pPr algn="ctr"/>
+          </a:p>
+        </p:txBody>
+      </p:sp>
+      <p:sp>
+        <p:nvSpPr>
+          <p:cNvPr id="48" name="Rectangle 47"/>
+          <p:cNvSpPr/>
+          <p:nvPr/>
+        </p:nvSpPr>
+        <p:spPr>
+          <a:xfrm>
+            <a:off x="7744968" y="3834993"/>
+            <a:ext cx="1152144" cy="241401"/>
+          </a:xfrm>
+          <a:prstGeom prst="rect">
+            <a:avLst/>
+          </a:prstGeom>
+          <a:noFill/>
+          <a:ln>
+            <a:noFill/>
+          </a:ln>
+          <a:effectLst/>
+        </p:spPr>
+        <p:style>
+          <a:lnRef idx="1">
+            <a:schemeClr val="accent1"/>
+          </a:lnRef>
+          <a:fillRef idx="3">
+            <a:schemeClr val="accent1"/>
+          </a:fillRef>
+          <a:effectRef idx="2">
+            <a:schemeClr val="accent1"/>
+          </a:effectRef>
+          <a:fontRef idx="minor">
+            <a:schemeClr val="lt1"/>
+          </a:fontRef>
+        </p:style>
+        <p:txBody>
+          <a:bodyPr rtlCol="0" anchor="ctr" wrap="none" lIns="0" rIns="0" tIns="0" bIns="0"/>
+          <a:lstStyle/>
+          <a:p>
+            <a:pPr algn="ctr"/>
+            <a:r>
+              <a:rPr sz="900" b="1">
+                <a:solidFill>
+                  <a:srgbClr val="2D9E4F"/>
+                </a:solidFill>
+                <a:latin typeface="Trebuchet MS"/>
+              </a:rPr>
+              <a:t>tak</a:t>
+            </a:r>
+          </a:p>
+        </p:txBody>
+      </p:sp>
+      <p:sp>
+        <p:nvSpPr>
+          <p:cNvPr id="49" name="Rectangle 48"/>
+          <p:cNvSpPr/>
+          <p:nvPr/>
+        </p:nvSpPr>
+        <p:spPr>
+          <a:xfrm>
+            <a:off x="201168" y="4076395"/>
+            <a:ext cx="2331720" cy="241401"/>
+          </a:xfrm>
+          <a:prstGeom prst="rect">
+            <a:avLst/>
+          </a:prstGeom>
+          <a:solidFill>
+            <a:srgbClr val="FFFFFF"/>
+          </a:solidFill>
+          <a:ln w="12700">
+            <a:solidFill>
+              <a:srgbClr val="D8E6EA"/>
+            </a:solidFill>
+          </a:ln>
+          <a:effectLst/>
+        </p:spPr>
+        <p:style>
+          <a:lnRef idx="1">
+            <a:schemeClr val="accent1"/>
+          </a:lnRef>
+          <a:fillRef idx="3">
+            <a:schemeClr val="accent1"/>
+          </a:fillRef>
+          <a:effectRef idx="2">
+            <a:schemeClr val="accent1"/>
+          </a:effectRef>
+          <a:fontRef idx="minor">
+            <a:schemeClr val="lt1"/>
+          </a:fontRef>
+        </p:style>
+        <p:txBody>
+          <a:bodyPr rtlCol="0" anchor="ctr"/>
+          <a:lstStyle/>
+          <a:p>
+            <a:pPr algn="ctr"/>
+          </a:p>
+        </p:txBody>
+      </p:sp>
+      <p:sp>
+        <p:nvSpPr>
+          <p:cNvPr id="50" name="Rectangle 49"/>
+          <p:cNvSpPr/>
+          <p:nvPr/>
+        </p:nvSpPr>
+        <p:spPr>
+          <a:xfrm>
+            <a:off x="246888" y="4076395"/>
+            <a:ext cx="2240279" cy="241401"/>
+          </a:xfrm>
+          <a:prstGeom prst="rect">
+            <a:avLst/>
+          </a:prstGeom>
+          <a:noFill/>
+          <a:ln>
+            <a:noFill/>
+          </a:ln>
+          <a:effectLst/>
+        </p:spPr>
+        <p:style>
+          <a:lnRef idx="1">
+            <a:schemeClr val="accent1"/>
+          </a:lnRef>
+          <a:fillRef idx="3">
+            <a:schemeClr val="accent1"/>
+          </a:fillRef>
+          <a:effectRef idx="2">
+            <a:schemeClr val="accent1"/>
+          </a:effectRef>
+          <a:fontRef idx="minor">
+            <a:schemeClr val="lt1"/>
+          </a:fontRef>
+        </p:style>
+        <p:txBody>
+          <a:bodyPr rtlCol="0" anchor="ctr" wrap="none" lIns="0" rIns="0" tIns="0" bIns="0"/>
+          <a:lstStyle/>
+          <a:p>
+            <a:pPr algn="l"/>
+            <a:r>
+              <a:rPr sz="900" b="1">
+                <a:solidFill>
+                  <a:srgbClr val="1A2B35"/>
+                </a:solidFill>
+                <a:latin typeface="Trebuchet MS"/>
+              </a:rPr>
+              <a:t>C. StatsBomb overlap, Δ=0</a:t>
+            </a:r>
+          </a:p>
+        </p:txBody>
+      </p:sp>
+      <p:sp>
+        <p:nvSpPr>
+          <p:cNvPr id="51" name="Rectangle 50"/>
+          <p:cNvSpPr/>
+          <p:nvPr/>
+        </p:nvSpPr>
+        <p:spPr>
+          <a:xfrm>
+            <a:off x="2532888" y="4076395"/>
+            <a:ext cx="594360" cy="241401"/>
+          </a:xfrm>
+          <a:prstGeom prst="rect">
+            <a:avLst/>
+          </a:prstGeom>
+          <a:solidFill>
+            <a:srgbClr val="FFFFFF"/>
+          </a:solidFill>
+          <a:ln w="12700">
+            <a:solidFill>
+              <a:srgbClr val="D8E6EA"/>
+            </a:solidFill>
+          </a:ln>
+          <a:effectLst/>
+        </p:spPr>
+        <p:style>
+          <a:lnRef idx="1">
+            <a:schemeClr val="accent1"/>
+          </a:lnRef>
+          <a:fillRef idx="3">
+            <a:schemeClr val="accent1"/>
+          </a:fillRef>
+          <a:effectRef idx="2">
+            <a:schemeClr val="accent1"/>
+          </a:effectRef>
+          <a:fontRef idx="minor">
+            <a:schemeClr val="lt1"/>
+          </a:fontRef>
+        </p:style>
+        <p:txBody>
+          <a:bodyPr rtlCol="0" anchor="ctr"/>
+          <a:lstStyle/>
+          <a:p>
+            <a:pPr algn="ctr"/>
+          </a:p>
+        </p:txBody>
+      </p:sp>
+      <p:sp>
+        <p:nvSpPr>
+          <p:cNvPr id="52" name="Rectangle 51"/>
+          <p:cNvSpPr/>
+          <p:nvPr/>
+        </p:nvSpPr>
+        <p:spPr>
+          <a:xfrm>
+            <a:off x="2578608" y="4076395"/>
+            <a:ext cx="502920" cy="241401"/>
+          </a:xfrm>
+          <a:prstGeom prst="rect">
+            <a:avLst/>
+          </a:prstGeom>
+          <a:noFill/>
+          <a:ln>
+            <a:noFill/>
+          </a:ln>
+          <a:effectLst/>
+        </p:spPr>
+        <p:style>
+          <a:lnRef idx="1">
+            <a:schemeClr val="accent1"/>
+          </a:lnRef>
+          <a:fillRef idx="3">
+            <a:schemeClr val="accent1"/>
+          </a:fillRef>
+          <a:effectRef idx="2">
+            <a:schemeClr val="accent1"/>
+          </a:effectRef>
+          <a:fontRef idx="minor">
+            <a:schemeClr val="lt1"/>
+          </a:fontRef>
+        </p:style>
+        <p:txBody>
+          <a:bodyPr rtlCol="0" anchor="ctr" wrap="none" lIns="0" rIns="0" tIns="0" bIns="0"/>
+          <a:lstStyle/>
+          <a:p>
+            <a:pPr algn="ctr"/>
+            <a:r>
+              <a:rPr sz="900" b="0">
+                <a:solidFill>
+                  <a:srgbClr val="1A2B35"/>
+                </a:solidFill>
+                <a:latin typeface="Consolas"/>
+              </a:rPr>
+              <a:t>0.706</a:t>
+            </a:r>
+          </a:p>
+        </p:txBody>
+      </p:sp>
+      <p:sp>
+        <p:nvSpPr>
+          <p:cNvPr id="53" name="Rectangle 52"/>
+          <p:cNvSpPr/>
+          <p:nvPr/>
+        </p:nvSpPr>
+        <p:spPr>
+          <a:xfrm>
+            <a:off x="3127248" y="4076395"/>
+            <a:ext cx="960120" cy="241401"/>
+          </a:xfrm>
+          <a:prstGeom prst="rect">
+            <a:avLst/>
+          </a:prstGeom>
+          <a:solidFill>
+            <a:srgbClr val="FFFFFF"/>
+          </a:solidFill>
+          <a:ln w="12700">
+            <a:solidFill>
+              <a:srgbClr val="D8E6EA"/>
+            </a:solidFill>
+          </a:ln>
+          <a:effectLst/>
+        </p:spPr>
+        <p:style>
+          <a:lnRef idx="1">
+            <a:schemeClr val="accent1"/>
+          </a:lnRef>
+          <a:fillRef idx="3">
+            <a:schemeClr val="accent1"/>
+          </a:fillRef>
+          <a:effectRef idx="2">
+            <a:schemeClr val="accent1"/>
+          </a:effectRef>
+          <a:fontRef idx="minor">
+            <a:schemeClr val="lt1"/>
+          </a:fontRef>
+        </p:style>
+        <p:txBody>
+          <a:bodyPr rtlCol="0" anchor="ctr"/>
+          <a:lstStyle/>
+          <a:p>
+            <a:pPr algn="ctr"/>
+          </a:p>
+        </p:txBody>
+      </p:sp>
+      <p:sp>
+        <p:nvSpPr>
+          <p:cNvPr id="54" name="Rectangle 53"/>
+          <p:cNvSpPr/>
+          <p:nvPr/>
+        </p:nvSpPr>
+        <p:spPr>
+          <a:xfrm>
+            <a:off x="3172968" y="4076395"/>
+            <a:ext cx="868680" cy="241401"/>
+          </a:xfrm>
+          <a:prstGeom prst="rect">
+            <a:avLst/>
+          </a:prstGeom>
+          <a:noFill/>
+          <a:ln>
+            <a:noFill/>
+          </a:ln>
+          <a:effectLst/>
+        </p:spPr>
+        <p:style>
+          <a:lnRef idx="1">
+            <a:schemeClr val="accent1"/>
+          </a:lnRef>
+          <a:fillRef idx="3">
+            <a:schemeClr val="accent1"/>
+          </a:fillRef>
+          <a:effectRef idx="2">
+            <a:schemeClr val="accent1"/>
+          </a:effectRef>
+          <a:fontRef idx="minor">
+            <a:schemeClr val="lt1"/>
+          </a:fontRef>
+        </p:style>
+        <p:txBody>
+          <a:bodyPr rtlCol="0" anchor="ctr" wrap="none" lIns="0" rIns="0" tIns="0" bIns="0"/>
+          <a:lstStyle/>
+          <a:p>
+            <a:pPr algn="ctr"/>
+            <a:r>
+              <a:rPr sz="900" b="0">
+                <a:solidFill>
+                  <a:srgbClr val="1A2B35"/>
+                </a:solidFill>
+                <a:latin typeface="Consolas"/>
+              </a:rPr>
+              <a:t>0.0000</a:t>
+            </a:r>
+          </a:p>
+        </p:txBody>
+      </p:sp>
+      <p:sp>
+        <p:nvSpPr>
+          <p:cNvPr id="55" name="Rectangle 54"/>
+          <p:cNvSpPr/>
+          <p:nvPr/>
+        </p:nvSpPr>
+        <p:spPr>
+          <a:xfrm>
+            <a:off x="4087368" y="4076395"/>
+            <a:ext cx="777240" cy="241401"/>
+          </a:xfrm>
+          <a:prstGeom prst="rect">
+            <a:avLst/>
+          </a:prstGeom>
+          <a:solidFill>
+            <a:srgbClr val="FFFFFF"/>
+          </a:solidFill>
+          <a:ln w="12700">
+            <a:solidFill>
+              <a:srgbClr val="D8E6EA"/>
+            </a:solidFill>
+          </a:ln>
+          <a:effectLst/>
+        </p:spPr>
+        <p:style>
+          <a:lnRef idx="1">
+            <a:schemeClr val="accent1"/>
+          </a:lnRef>
+          <a:fillRef idx="3">
+            <a:schemeClr val="accent1"/>
+          </a:fillRef>
+          <a:effectRef idx="2">
+            <a:schemeClr val="accent1"/>
+          </a:effectRef>
+          <a:fontRef idx="minor">
+            <a:schemeClr val="lt1"/>
+          </a:fontRef>
+        </p:style>
+        <p:txBody>
+          <a:bodyPr rtlCol="0" anchor="ctr"/>
+          <a:lstStyle/>
+          <a:p>
+            <a:pPr algn="ctr"/>
+          </a:p>
+        </p:txBody>
+      </p:sp>
+      <p:sp>
+        <p:nvSpPr>
+          <p:cNvPr id="56" name="Rectangle 55"/>
+          <p:cNvSpPr/>
+          <p:nvPr/>
+        </p:nvSpPr>
+        <p:spPr>
+          <a:xfrm>
+            <a:off x="4133087" y="4076395"/>
+            <a:ext cx="685800" cy="241401"/>
+          </a:xfrm>
+          <a:prstGeom prst="rect">
+            <a:avLst/>
+          </a:prstGeom>
+          <a:noFill/>
+          <a:ln>
+            <a:noFill/>
+          </a:ln>
+          <a:effectLst/>
+        </p:spPr>
+        <p:style>
+          <a:lnRef idx="1">
+            <a:schemeClr val="accent1"/>
+          </a:lnRef>
+          <a:fillRef idx="3">
+            <a:schemeClr val="accent1"/>
+          </a:fillRef>
+          <a:effectRef idx="2">
+            <a:schemeClr val="accent1"/>
+          </a:effectRef>
+          <a:fontRef idx="minor">
+            <a:schemeClr val="lt1"/>
+          </a:fontRef>
+        </p:style>
+        <p:txBody>
+          <a:bodyPr rtlCol="0" anchor="ctr" wrap="none" lIns="0" rIns="0" tIns="0" bIns="0"/>
+          <a:lstStyle/>
+          <a:p>
+            <a:pPr algn="ctr"/>
+            <a:r>
+              <a:rPr sz="900" b="1">
+                <a:solidFill>
+                  <a:srgbClr val="7C60D4"/>
+                </a:solidFill>
+                <a:latin typeface="Trebuchet MS"/>
+              </a:rPr>
+              <a:t>0.02162</a:t>
+            </a:r>
+          </a:p>
+        </p:txBody>
+      </p:sp>
+      <p:sp>
+        <p:nvSpPr>
+          <p:cNvPr id="57" name="Rectangle 56"/>
+          <p:cNvSpPr/>
+          <p:nvPr/>
+        </p:nvSpPr>
+        <p:spPr>
+          <a:xfrm>
+            <a:off x="4864607" y="4076395"/>
+            <a:ext cx="1600200" cy="241401"/>
+          </a:xfrm>
+          <a:prstGeom prst="rect">
+            <a:avLst/>
+          </a:prstGeom>
+          <a:solidFill>
+            <a:srgbClr val="FFFFFF"/>
+          </a:solidFill>
+          <a:ln w="12700">
+            <a:solidFill>
+              <a:srgbClr val="D8E6EA"/>
+            </a:solidFill>
+          </a:ln>
+          <a:effectLst/>
+        </p:spPr>
+        <p:style>
+          <a:lnRef idx="1">
+            <a:schemeClr val="accent1"/>
+          </a:lnRef>
+          <a:fillRef idx="3">
+            <a:schemeClr val="accent1"/>
+          </a:fillRef>
+          <a:effectRef idx="2">
+            <a:schemeClr val="accent1"/>
+          </a:effectRef>
+          <a:fontRef idx="minor">
+            <a:schemeClr val="lt1"/>
+          </a:fontRef>
+        </p:style>
+        <p:txBody>
+          <a:bodyPr rtlCol="0" anchor="ctr"/>
+          <a:lstStyle/>
+          <a:p>
+            <a:pPr algn="ctr"/>
+          </a:p>
+        </p:txBody>
+      </p:sp>
+      <p:sp>
+        <p:nvSpPr>
+          <p:cNvPr id="58" name="Rectangle 57"/>
+          <p:cNvSpPr/>
+          <p:nvPr/>
+        </p:nvSpPr>
+        <p:spPr>
+          <a:xfrm>
+            <a:off x="4910327" y="4076395"/>
+            <a:ext cx="1508760" cy="241401"/>
+          </a:xfrm>
+          <a:prstGeom prst="rect">
+            <a:avLst/>
+          </a:prstGeom>
+          <a:noFill/>
+          <a:ln>
+            <a:noFill/>
+          </a:ln>
+          <a:effectLst/>
+        </p:spPr>
+        <p:style>
+          <a:lnRef idx="1">
+            <a:schemeClr val="accent1"/>
+          </a:lnRef>
+          <a:fillRef idx="3">
+            <a:schemeClr val="accent1"/>
+          </a:fillRef>
+          <a:effectRef idx="2">
+            <a:schemeClr val="accent1"/>
+          </a:effectRef>
+          <a:fontRef idx="minor">
+            <a:schemeClr val="lt1"/>
+          </a:fontRef>
+        </p:style>
+        <p:txBody>
+          <a:bodyPr rtlCol="0" anchor="ctr" wrap="none" lIns="0" rIns="0" tIns="0" bIns="0"/>
+          <a:lstStyle/>
+          <a:p>
+            <a:pPr algn="ctr"/>
+            <a:r>
+              <a:rPr sz="850" b="0">
+                <a:solidFill>
+                  <a:srgbClr val="1A2B35"/>
+                </a:solidFill>
+                <a:latin typeface="Consolas"/>
+              </a:rPr>
+              <a:t>[0.0193, 0.0238]</a:t>
+            </a:r>
+          </a:p>
+        </p:txBody>
+      </p:sp>
+      <p:sp>
+        <p:nvSpPr>
+          <p:cNvPr id="59" name="Rectangle 58"/>
+          <p:cNvSpPr/>
+          <p:nvPr/>
+        </p:nvSpPr>
+        <p:spPr>
+          <a:xfrm>
+            <a:off x="6464807" y="4076395"/>
+            <a:ext cx="1234440" cy="241401"/>
+          </a:xfrm>
+          <a:prstGeom prst="rect">
+            <a:avLst/>
+          </a:prstGeom>
+          <a:solidFill>
+            <a:srgbClr val="FFFFFF"/>
+          </a:solidFill>
+          <a:ln w="12700">
+            <a:solidFill>
+              <a:srgbClr val="D8E6EA"/>
+            </a:solidFill>
+          </a:ln>
+          <a:effectLst/>
+        </p:spPr>
+        <p:style>
+          <a:lnRef idx="1">
+            <a:schemeClr val="accent1"/>
+          </a:lnRef>
+          <a:fillRef idx="3">
+            <a:schemeClr val="accent1"/>
+          </a:fillRef>
+          <a:effectRef idx="2">
+            <a:schemeClr val="accent1"/>
+          </a:effectRef>
+          <a:fontRef idx="minor">
+            <a:schemeClr val="lt1"/>
+          </a:fontRef>
+        </p:style>
+        <p:txBody>
+          <a:bodyPr rtlCol="0" anchor="ctr"/>
+          <a:lstStyle/>
+          <a:p>
+            <a:pPr algn="ctr"/>
+          </a:p>
+        </p:txBody>
+      </p:sp>
+      <p:sp>
+        <p:nvSpPr>
+          <p:cNvPr id="60" name="Rectangle 59"/>
+          <p:cNvSpPr/>
+          <p:nvPr/>
+        </p:nvSpPr>
+        <p:spPr>
+          <a:xfrm>
+            <a:off x="6510527" y="4076395"/>
+            <a:ext cx="1143000" cy="241401"/>
+          </a:xfrm>
+          <a:prstGeom prst="rect">
+            <a:avLst/>
+          </a:prstGeom>
+          <a:noFill/>
+          <a:ln>
+            <a:noFill/>
+          </a:ln>
+          <a:effectLst/>
+        </p:spPr>
+        <p:style>
+          <a:lnRef idx="1">
+            <a:schemeClr val="accent1"/>
+          </a:lnRef>
+          <a:fillRef idx="3">
+            <a:schemeClr val="accent1"/>
+          </a:fillRef>
+          <a:effectRef idx="2">
+            <a:schemeClr val="accent1"/>
+          </a:effectRef>
+          <a:fontRef idx="minor">
+            <a:schemeClr val="lt1"/>
+          </a:fontRef>
+        </p:style>
+        <p:txBody>
+          <a:bodyPr rtlCol="0" anchor="ctr" wrap="none" lIns="0" rIns="0" tIns="0" bIns="0"/>
+          <a:lstStyle/>
+          <a:p>
+            <a:pPr algn="ctr"/>
+            <a:r>
+              <a:rPr sz="900" b="1">
+                <a:solidFill>
+                  <a:srgbClr val="2D9E4F"/>
+                </a:solidFill>
+                <a:latin typeface="Trebuchet MS"/>
+              </a:rPr>
+              <a:t>tak</a:t>
+            </a:r>
+          </a:p>
+        </p:txBody>
+      </p:sp>
+      <p:sp>
+        <p:nvSpPr>
+          <p:cNvPr id="61" name="Rectangle 60"/>
+          <p:cNvSpPr/>
+          <p:nvPr/>
+        </p:nvSpPr>
+        <p:spPr>
+          <a:xfrm>
+            <a:off x="7699248" y="4076395"/>
+            <a:ext cx="1243584" cy="241401"/>
+          </a:xfrm>
+          <a:prstGeom prst="rect">
+            <a:avLst/>
+          </a:prstGeom>
+          <a:solidFill>
+            <a:srgbClr val="FFFFFF"/>
+          </a:solidFill>
+          <a:ln w="12700">
+            <a:solidFill>
+              <a:srgbClr val="D8E6EA"/>
+            </a:solidFill>
+          </a:ln>
+          <a:effectLst/>
+        </p:spPr>
+        <p:style>
+          <a:lnRef idx="1">
+            <a:schemeClr val="accent1"/>
+          </a:lnRef>
+          <a:fillRef idx="3">
+            <a:schemeClr val="accent1"/>
+          </a:fillRef>
+          <a:effectRef idx="2">
+            <a:schemeClr val="accent1"/>
+          </a:effectRef>
+          <a:fontRef idx="minor">
+            <a:schemeClr val="lt1"/>
+          </a:fontRef>
+        </p:style>
+        <p:txBody>
+          <a:bodyPr rtlCol="0" anchor="ctr"/>
+          <a:lstStyle/>
+          <a:p>
+            <a:pPr algn="ctr"/>
+          </a:p>
+        </p:txBody>
+      </p:sp>
+      <p:sp>
+        <p:nvSpPr>
+          <p:cNvPr id="62" name="Rectangle 61"/>
+          <p:cNvSpPr/>
+          <p:nvPr/>
+        </p:nvSpPr>
+        <p:spPr>
+          <a:xfrm>
+            <a:off x="7744968" y="4076395"/>
+            <a:ext cx="1152144" cy="241401"/>
+          </a:xfrm>
+          <a:prstGeom prst="rect">
+            <a:avLst/>
+          </a:prstGeom>
+          <a:noFill/>
+          <a:ln>
+            <a:noFill/>
+          </a:ln>
+          <a:effectLst/>
+        </p:spPr>
+        <p:style>
+          <a:lnRef idx="1">
+            <a:schemeClr val="accent1"/>
+          </a:lnRef>
+          <a:fillRef idx="3">
+            <a:schemeClr val="accent1"/>
+          </a:fillRef>
+          <a:effectRef idx="2">
+            <a:schemeClr val="accent1"/>
+          </a:effectRef>
+          <a:fontRef idx="minor">
+            <a:schemeClr val="lt1"/>
+          </a:fontRef>
+        </p:style>
+        <p:txBody>
+          <a:bodyPr rtlCol="0" anchor="ctr" wrap="none" lIns="0" rIns="0" tIns="0" bIns="0"/>
+          <a:lstStyle/>
+          <a:p>
+            <a:pPr algn="ctr"/>
+            <a:r>
+              <a:rPr sz="900" b="1">
+                <a:solidFill>
+                  <a:srgbClr val="2D9E4F"/>
+                </a:solidFill>
+                <a:latin typeface="Trebuchet MS"/>
+              </a:rPr>
+              <a:t>tak</a:t>
+            </a:r>
+          </a:p>
+        </p:txBody>
+      </p:sp>
+      <p:sp>
+        <p:nvSpPr>
+          <p:cNvPr id="63" name="Rectangle 62"/>
+          <p:cNvSpPr/>
+          <p:nvPr/>
+        </p:nvSpPr>
+        <p:spPr>
+          <a:xfrm>
+            <a:off x="201168" y="4317796"/>
+            <a:ext cx="2331720" cy="241401"/>
+          </a:xfrm>
+          <a:prstGeom prst="rect">
+            <a:avLst/>
+          </a:prstGeom>
+          <a:solidFill>
+            <a:srgbClr val="F4F7F8"/>
+          </a:solidFill>
+          <a:ln w="12700">
+            <a:solidFill>
+              <a:srgbClr val="D8E6EA"/>
+            </a:solidFill>
+          </a:ln>
+          <a:effectLst/>
+        </p:spPr>
+        <p:style>
+          <a:lnRef idx="1">
+            <a:schemeClr val="accent1"/>
+          </a:lnRef>
+          <a:fillRef idx="3">
+            <a:schemeClr val="accent1"/>
+          </a:fillRef>
+          <a:effectRef idx="2">
+            <a:schemeClr val="accent1"/>
+          </a:effectRef>
+          <a:fontRef idx="minor">
+            <a:schemeClr val="lt1"/>
+          </a:fontRef>
+        </p:style>
+        <p:txBody>
+          <a:bodyPr rtlCol="0" anchor="ctr"/>
+          <a:lstStyle/>
+          <a:p>
+            <a:pPr algn="ctr"/>
+          </a:p>
+        </p:txBody>
+      </p:sp>
+      <p:sp>
+        <p:nvSpPr>
+          <p:cNvPr id="64" name="Rectangle 63"/>
+          <p:cNvSpPr/>
+          <p:nvPr/>
+        </p:nvSpPr>
+        <p:spPr>
+          <a:xfrm>
+            <a:off x="246888" y="4317796"/>
+            <a:ext cx="2240279" cy="241401"/>
+          </a:xfrm>
+          <a:prstGeom prst="rect">
+            <a:avLst/>
+          </a:prstGeom>
+          <a:noFill/>
+          <a:ln>
+            <a:noFill/>
+          </a:ln>
+          <a:effectLst/>
+        </p:spPr>
+        <p:style>
+          <a:lnRef idx="1">
+            <a:schemeClr val="accent1"/>
+          </a:lnRef>
+          <a:fillRef idx="3">
+            <a:schemeClr val="accent1"/>
+          </a:fillRef>
+          <a:effectRef idx="2">
+            <a:schemeClr val="accent1"/>
+          </a:effectRef>
+          <a:fontRef idx="minor">
+            <a:schemeClr val="lt1"/>
+          </a:fontRef>
+        </p:style>
+        <p:txBody>
+          <a:bodyPr rtlCol="0" anchor="ctr" wrap="none" lIns="0" rIns="0" tIns="0" bIns="0"/>
+          <a:lstStyle/>
+          <a:p>
+            <a:pPr algn="l"/>
+            <a:r>
+              <a:rPr sz="900" b="1">
+                <a:solidFill>
+                  <a:srgbClr val="1A2B35"/>
+                </a:solidFill>
+                <a:latin typeface="Trebuchet MS"/>
+              </a:rPr>
+              <a:t>D. StatsBomb overlap, Δ=mały</a:t>
+            </a:r>
+          </a:p>
+        </p:txBody>
+      </p:sp>
+      <p:sp>
+        <p:nvSpPr>
+          <p:cNvPr id="65" name="Rectangle 64"/>
+          <p:cNvSpPr/>
+          <p:nvPr/>
+        </p:nvSpPr>
+        <p:spPr>
+          <a:xfrm>
+            <a:off x="2532888" y="4317796"/>
+            <a:ext cx="594360" cy="241401"/>
+          </a:xfrm>
+          <a:prstGeom prst="rect">
+            <a:avLst/>
+          </a:prstGeom>
+          <a:solidFill>
+            <a:srgbClr val="F4F7F8"/>
+          </a:solidFill>
+          <a:ln w="12700">
+            <a:solidFill>
+              <a:srgbClr val="D8E6EA"/>
+            </a:solidFill>
+          </a:ln>
+          <a:effectLst/>
+        </p:spPr>
+        <p:style>
+          <a:lnRef idx="1">
+            <a:schemeClr val="accent1"/>
+          </a:lnRef>
+          <a:fillRef idx="3">
+            <a:schemeClr val="accent1"/>
+          </a:fillRef>
+          <a:effectRef idx="2">
+            <a:schemeClr val="accent1"/>
+          </a:effectRef>
+          <a:fontRef idx="minor">
+            <a:schemeClr val="lt1"/>
+          </a:fontRef>
+        </p:style>
+        <p:txBody>
+          <a:bodyPr rtlCol="0" anchor="ctr"/>
+          <a:lstStyle/>
+          <a:p>
+            <a:pPr algn="ctr"/>
+          </a:p>
+        </p:txBody>
+      </p:sp>
+      <p:sp>
+        <p:nvSpPr>
+          <p:cNvPr id="66" name="Rectangle 65"/>
+          <p:cNvSpPr/>
+          <p:nvPr/>
+        </p:nvSpPr>
+        <p:spPr>
+          <a:xfrm>
+            <a:off x="2578608" y="4317796"/>
+            <a:ext cx="502920" cy="241401"/>
+          </a:xfrm>
+          <a:prstGeom prst="rect">
+            <a:avLst/>
+          </a:prstGeom>
+          <a:noFill/>
+          <a:ln>
+            <a:noFill/>
+          </a:ln>
+          <a:effectLst/>
+        </p:spPr>
+        <p:style>
+          <a:lnRef idx="1">
+            <a:schemeClr val="accent1"/>
+          </a:lnRef>
+          <a:fillRef idx="3">
+            <a:schemeClr val="accent1"/>
+          </a:fillRef>
+          <a:effectRef idx="2">
+            <a:schemeClr val="accent1"/>
+          </a:effectRef>
+          <a:fontRef idx="minor">
+            <a:schemeClr val="lt1"/>
+          </a:fontRef>
+        </p:style>
+        <p:txBody>
+          <a:bodyPr rtlCol="0" anchor="ctr" wrap="none" lIns="0" rIns="0" tIns="0" bIns="0"/>
+          <a:lstStyle/>
+          <a:p>
+            <a:pPr algn="ctr"/>
+            <a:r>
+              <a:rPr sz="900" b="0">
+                <a:solidFill>
+                  <a:srgbClr val="1A2B35"/>
+                </a:solidFill>
+                <a:latin typeface="Consolas"/>
+              </a:rPr>
+              <a:t>0.706</a:t>
+            </a:r>
+          </a:p>
+        </p:txBody>
+      </p:sp>
+      <p:sp>
+        <p:nvSpPr>
+          <p:cNvPr id="67" name="Rectangle 66"/>
+          <p:cNvSpPr/>
+          <p:nvPr/>
+        </p:nvSpPr>
+        <p:spPr>
+          <a:xfrm>
+            <a:off x="3127248" y="4317796"/>
+            <a:ext cx="960120" cy="241401"/>
+          </a:xfrm>
+          <a:prstGeom prst="rect">
+            <a:avLst/>
+          </a:prstGeom>
+          <a:solidFill>
+            <a:srgbClr val="F4F7F8"/>
+          </a:solidFill>
+          <a:ln w="12700">
+            <a:solidFill>
+              <a:srgbClr val="D8E6EA"/>
+            </a:solidFill>
+          </a:ln>
+          <a:effectLst/>
+        </p:spPr>
+        <p:style>
+          <a:lnRef idx="1">
+            <a:schemeClr val="accent1"/>
+          </a:lnRef>
+          <a:fillRef idx="3">
+            <a:schemeClr val="accent1"/>
+          </a:fillRef>
+          <a:effectRef idx="2">
+            <a:schemeClr val="accent1"/>
+          </a:effectRef>
+          <a:fontRef idx="minor">
+            <a:schemeClr val="lt1"/>
+          </a:fontRef>
+        </p:style>
+        <p:txBody>
+          <a:bodyPr rtlCol="0" anchor="ctr"/>
+          <a:lstStyle/>
+          <a:p>
+            <a:pPr algn="ctr"/>
+          </a:p>
+        </p:txBody>
+      </p:sp>
+      <p:sp>
+        <p:nvSpPr>
+          <p:cNvPr id="68" name="Rectangle 67"/>
+          <p:cNvSpPr/>
+          <p:nvPr/>
+        </p:nvSpPr>
+        <p:spPr>
+          <a:xfrm>
+            <a:off x="3172968" y="4317796"/>
+            <a:ext cx="868680" cy="241401"/>
+          </a:xfrm>
+          <a:prstGeom prst="rect">
+            <a:avLst/>
+          </a:prstGeom>
+          <a:noFill/>
+          <a:ln>
+            <a:noFill/>
+          </a:ln>
+          <a:effectLst/>
+        </p:spPr>
+        <p:style>
+          <a:lnRef idx="1">
+            <a:schemeClr val="accent1"/>
+          </a:lnRef>
+          <a:fillRef idx="3">
+            <a:schemeClr val="accent1"/>
+          </a:fillRef>
+          <a:effectRef idx="2">
+            <a:schemeClr val="accent1"/>
+          </a:effectRef>
+          <a:fontRef idx="minor">
+            <a:schemeClr val="lt1"/>
+          </a:fontRef>
+        </p:style>
+        <p:txBody>
+          <a:bodyPr rtlCol="0" anchor="ctr" wrap="none" lIns="0" rIns="0" tIns="0" bIns="0"/>
+          <a:lstStyle/>
+          <a:p>
+            <a:pPr algn="ctr"/>
+            <a:r>
+              <a:rPr sz="900" b="0">
+                <a:solidFill>
+                  <a:srgbClr val="1A2B35"/>
+                </a:solidFill>
+                <a:latin typeface="Consolas"/>
+              </a:rPr>
+              <a:t>+0.0012</a:t>
+            </a:r>
+          </a:p>
+        </p:txBody>
+      </p:sp>
+      <p:sp>
+        <p:nvSpPr>
+          <p:cNvPr id="69" name="Rectangle 68"/>
+          <p:cNvSpPr/>
+          <p:nvPr/>
+        </p:nvSpPr>
+        <p:spPr>
+          <a:xfrm>
+            <a:off x="4087368" y="4317796"/>
+            <a:ext cx="777240" cy="241401"/>
+          </a:xfrm>
+          <a:prstGeom prst="rect">
+            <a:avLst/>
+          </a:prstGeom>
+          <a:solidFill>
+            <a:srgbClr val="F4F7F8"/>
+          </a:solidFill>
+          <a:ln w="12700">
+            <a:solidFill>
+              <a:srgbClr val="D8E6EA"/>
+            </a:solidFill>
+          </a:ln>
+          <a:effectLst/>
+        </p:spPr>
+        <p:style>
+          <a:lnRef idx="1">
+            <a:schemeClr val="accent1"/>
+          </a:lnRef>
+          <a:fillRef idx="3">
+            <a:schemeClr val="accent1"/>
+          </a:fillRef>
+          <a:effectRef idx="2">
+            <a:schemeClr val="accent1"/>
+          </a:effectRef>
+          <a:fontRef idx="minor">
+            <a:schemeClr val="lt1"/>
+          </a:fontRef>
+        </p:style>
+        <p:txBody>
+          <a:bodyPr rtlCol="0" anchor="ctr"/>
+          <a:lstStyle/>
+          <a:p>
+            <a:pPr algn="ctr"/>
+          </a:p>
+        </p:txBody>
+      </p:sp>
+      <p:sp>
+        <p:nvSpPr>
+          <p:cNvPr id="70" name="Rectangle 69"/>
+          <p:cNvSpPr/>
+          <p:nvPr/>
+        </p:nvSpPr>
+        <p:spPr>
+          <a:xfrm>
+            <a:off x="4133087" y="4317796"/>
+            <a:ext cx="685800" cy="241401"/>
+          </a:xfrm>
+          <a:prstGeom prst="rect">
+            <a:avLst/>
+          </a:prstGeom>
+          <a:noFill/>
+          <a:ln>
+            <a:noFill/>
+          </a:ln>
+          <a:effectLst/>
+        </p:spPr>
+        <p:style>
+          <a:lnRef idx="1">
+            <a:schemeClr val="accent1"/>
+          </a:lnRef>
+          <a:fillRef idx="3">
+            <a:schemeClr val="accent1"/>
+          </a:fillRef>
+          <a:effectRef idx="2">
+            <a:schemeClr val="accent1"/>
+          </a:effectRef>
+          <a:fontRef idx="minor">
+            <a:schemeClr val="lt1"/>
+          </a:fontRef>
+        </p:style>
+        <p:txBody>
+          <a:bodyPr rtlCol="0" anchor="ctr" wrap="none" lIns="0" rIns="0" tIns="0" bIns="0"/>
+          <a:lstStyle/>
+          <a:p>
+            <a:pPr algn="ctr"/>
+            <a:r>
+              <a:rPr sz="900" b="1">
+                <a:solidFill>
+                  <a:srgbClr val="7C60D4"/>
+                </a:solidFill>
+                <a:latin typeface="Trebuchet MS"/>
+              </a:rPr>
+              <a:t>0.03241</a:t>
+            </a:r>
+          </a:p>
+        </p:txBody>
+      </p:sp>
+      <p:sp>
+        <p:nvSpPr>
+          <p:cNvPr id="71" name="Rectangle 70"/>
+          <p:cNvSpPr/>
+          <p:nvPr/>
+        </p:nvSpPr>
+        <p:spPr>
+          <a:xfrm>
+            <a:off x="4864607" y="4317796"/>
+            <a:ext cx="1600200" cy="241401"/>
+          </a:xfrm>
+          <a:prstGeom prst="rect">
+            <a:avLst/>
+          </a:prstGeom>
+          <a:solidFill>
+            <a:srgbClr val="F4F7F8"/>
+          </a:solidFill>
+          <a:ln w="12700">
+            <a:solidFill>
+              <a:srgbClr val="D8E6EA"/>
+            </a:solidFill>
+          </a:ln>
+          <a:effectLst/>
+        </p:spPr>
+        <p:style>
+          <a:lnRef idx="1">
+            <a:schemeClr val="accent1"/>
+          </a:lnRef>
+          <a:fillRef idx="3">
+            <a:schemeClr val="accent1"/>
+          </a:fillRef>
+          <a:effectRef idx="2">
+            <a:schemeClr val="accent1"/>
+          </a:effectRef>
+          <a:fontRef idx="minor">
+            <a:schemeClr val="lt1"/>
+          </a:fontRef>
+        </p:style>
+        <p:txBody>
+          <a:bodyPr rtlCol="0" anchor="ctr"/>
+          <a:lstStyle/>
+          <a:p>
+            <a:pPr algn="ctr"/>
+          </a:p>
+        </p:txBody>
+      </p:sp>
+      <p:sp>
+        <p:nvSpPr>
+          <p:cNvPr id="72" name="Rectangle 71"/>
+          <p:cNvSpPr/>
+          <p:nvPr/>
+        </p:nvSpPr>
+        <p:spPr>
+          <a:xfrm>
+            <a:off x="4910327" y="4317796"/>
+            <a:ext cx="1508760" cy="241401"/>
+          </a:xfrm>
+          <a:prstGeom prst="rect">
+            <a:avLst/>
+          </a:prstGeom>
+          <a:noFill/>
+          <a:ln>
+            <a:noFill/>
+          </a:ln>
+          <a:effectLst/>
+        </p:spPr>
+        <p:style>
+          <a:lnRef idx="1">
+            <a:schemeClr val="accent1"/>
+          </a:lnRef>
+          <a:fillRef idx="3">
+            <a:schemeClr val="accent1"/>
+          </a:fillRef>
+          <a:effectRef idx="2">
+            <a:schemeClr val="accent1"/>
+          </a:effectRef>
+          <a:fontRef idx="minor">
+            <a:schemeClr val="lt1"/>
+          </a:fontRef>
+        </p:style>
+        <p:txBody>
+          <a:bodyPr rtlCol="0" anchor="ctr" wrap="none" lIns="0" rIns="0" tIns="0" bIns="0"/>
+          <a:lstStyle/>
+          <a:p>
+            <a:pPr algn="ctr"/>
+            <a:r>
+              <a:rPr sz="850" b="0">
+                <a:solidFill>
+                  <a:srgbClr val="1A2B35"/>
+                </a:solidFill>
+                <a:latin typeface="Consolas"/>
+              </a:rPr>
+              <a:t>[0.0296, 0.0354]</a:t>
+            </a:r>
+          </a:p>
+        </p:txBody>
+      </p:sp>
+      <p:sp>
+        <p:nvSpPr>
+          <p:cNvPr id="73" name="Rectangle 72"/>
+          <p:cNvSpPr/>
+          <p:nvPr/>
+        </p:nvSpPr>
+        <p:spPr>
+          <a:xfrm>
+            <a:off x="6464807" y="4317796"/>
+            <a:ext cx="1234440" cy="241401"/>
+          </a:xfrm>
+          <a:prstGeom prst="rect">
+            <a:avLst/>
+          </a:prstGeom>
+          <a:solidFill>
+            <a:srgbClr val="F4F7F8"/>
+          </a:solidFill>
+          <a:ln w="12700">
+            <a:solidFill>
+              <a:srgbClr val="D8E6EA"/>
+            </a:solidFill>
+          </a:ln>
+          <a:effectLst/>
+        </p:spPr>
+        <p:style>
+          <a:lnRef idx="1">
+            <a:schemeClr val="accent1"/>
+          </a:lnRef>
+          <a:fillRef idx="3">
+            <a:schemeClr val="accent1"/>
+          </a:fillRef>
+          <a:effectRef idx="2">
+            <a:schemeClr val="accent1"/>
+          </a:effectRef>
+          <a:fontRef idx="minor">
+            <a:schemeClr val="lt1"/>
+          </a:fontRef>
+        </p:style>
+        <p:txBody>
+          <a:bodyPr rtlCol="0" anchor="ctr"/>
+          <a:lstStyle/>
+          <a:p>
+            <a:pPr algn="ctr"/>
+          </a:p>
+        </p:txBody>
+      </p:sp>
+      <p:sp>
+        <p:nvSpPr>
+          <p:cNvPr id="74" name="Rectangle 73"/>
+          <p:cNvSpPr/>
+          <p:nvPr/>
+        </p:nvSpPr>
+        <p:spPr>
+          <a:xfrm>
+            <a:off x="6510527" y="4317796"/>
+            <a:ext cx="1143000" cy="241401"/>
+          </a:xfrm>
+          <a:prstGeom prst="rect">
+            <a:avLst/>
+          </a:prstGeom>
+          <a:noFill/>
+          <a:ln>
+            <a:noFill/>
+          </a:ln>
+          <a:effectLst/>
+        </p:spPr>
+        <p:style>
+          <a:lnRef idx="1">
+            <a:schemeClr val="accent1"/>
+          </a:lnRef>
+          <a:fillRef idx="3">
+            <a:schemeClr val="accent1"/>
+          </a:fillRef>
+          <a:effectRef idx="2">
+            <a:schemeClr val="accent1"/>
+          </a:effectRef>
+          <a:fontRef idx="minor">
+            <a:schemeClr val="lt1"/>
+          </a:fontRef>
+        </p:style>
+        <p:txBody>
+          <a:bodyPr rtlCol="0" anchor="ctr" wrap="none" lIns="0" rIns="0" tIns="0" bIns="0"/>
+          <a:lstStyle/>
+          <a:p>
+            <a:pPr algn="ctr"/>
+            <a:r>
+              <a:rPr sz="900" b="1">
+                <a:solidFill>
+                  <a:srgbClr val="2D9E4F"/>
+                </a:solidFill>
+                <a:latin typeface="Trebuchet MS"/>
+              </a:rPr>
+              <a:t>tak</a:t>
+            </a:r>
+          </a:p>
+        </p:txBody>
+      </p:sp>
+      <p:sp>
+        <p:nvSpPr>
+          <p:cNvPr id="75" name="Rectangle 74"/>
+          <p:cNvSpPr/>
+          <p:nvPr/>
+        </p:nvSpPr>
+        <p:spPr>
+          <a:xfrm>
+            <a:off x="7699248" y="4317796"/>
+            <a:ext cx="1243584" cy="241401"/>
+          </a:xfrm>
+          <a:prstGeom prst="rect">
+            <a:avLst/>
+          </a:prstGeom>
+          <a:solidFill>
+            <a:srgbClr val="F4F7F8"/>
+          </a:solidFill>
+          <a:ln w="12700">
+            <a:solidFill>
+              <a:srgbClr val="D8E6EA"/>
+            </a:solidFill>
+          </a:ln>
+          <a:effectLst/>
+        </p:spPr>
+        <p:style>
+          <a:lnRef idx="1">
+            <a:schemeClr val="accent1"/>
+          </a:lnRef>
+          <a:fillRef idx="3">
+            <a:schemeClr val="accent1"/>
+          </a:fillRef>
+          <a:effectRef idx="2">
+            <a:schemeClr val="accent1"/>
+          </a:effectRef>
+          <a:fontRef idx="minor">
+            <a:schemeClr val="lt1"/>
+          </a:fontRef>
+        </p:style>
+        <p:txBody>
+          <a:bodyPr rtlCol="0" anchor="ctr"/>
+          <a:lstStyle/>
+          <a:p>
+            <a:pPr algn="ctr"/>
+          </a:p>
+        </p:txBody>
+      </p:sp>
+      <p:sp>
+        <p:nvSpPr>
+          <p:cNvPr id="76" name="Rectangle 75"/>
+          <p:cNvSpPr/>
+          <p:nvPr/>
+        </p:nvSpPr>
+        <p:spPr>
+          <a:xfrm>
+            <a:off x="7744968" y="4317796"/>
+            <a:ext cx="1152144" cy="241401"/>
+          </a:xfrm>
+          <a:prstGeom prst="rect">
+            <a:avLst/>
+          </a:prstGeom>
+          <a:noFill/>
+          <a:ln>
+            <a:noFill/>
+          </a:ln>
+          <a:effectLst/>
+        </p:spPr>
+        <p:style>
+          <a:lnRef idx="1">
+            <a:schemeClr val="accent1"/>
+          </a:lnRef>
+          <a:fillRef idx="3">
+            <a:schemeClr val="accent1"/>
+          </a:fillRef>
+          <a:effectRef idx="2">
+            <a:schemeClr val="accent1"/>
+          </a:effectRef>
+          <a:fontRef idx="minor">
+            <a:schemeClr val="lt1"/>
+          </a:fontRef>
+        </p:style>
+        <p:txBody>
+          <a:bodyPr rtlCol="0" anchor="ctr" wrap="none" lIns="0" rIns="0" tIns="0" bIns="0"/>
+          <a:lstStyle/>
+          <a:p>
+            <a:pPr algn="ctr"/>
+            <a:r>
+              <a:rPr sz="900" b="1">
+                <a:solidFill>
+                  <a:srgbClr val="2D9E4F"/>
+                </a:solidFill>
+                <a:latin typeface="Trebuchet MS"/>
+              </a:rPr>
+              <a:t>tak</a:t>
+            </a:r>
+          </a:p>
+        </p:txBody>
+      </p:sp>
+      <p:sp>
+        <p:nvSpPr>
+          <p:cNvPr id="77" name="Rectangle 76"/>
+          <p:cNvSpPr/>
+          <p:nvPr/>
+        </p:nvSpPr>
+        <p:spPr>
+          <a:xfrm>
+            <a:off x="201168" y="4559198"/>
+            <a:ext cx="2331720" cy="241401"/>
+          </a:xfrm>
+          <a:prstGeom prst="rect">
+            <a:avLst/>
+          </a:prstGeom>
+          <a:solidFill>
+            <a:srgbClr val="FFFFFF"/>
+          </a:solidFill>
+          <a:ln w="12700">
+            <a:solidFill>
+              <a:srgbClr val="D8E6EA"/>
+            </a:solidFill>
+          </a:ln>
+          <a:effectLst/>
+        </p:spPr>
+        <p:style>
+          <a:lnRef idx="1">
+            <a:schemeClr val="accent1"/>
+          </a:lnRef>
+          <a:fillRef idx="3">
+            <a:schemeClr val="accent1"/>
+          </a:fillRef>
+          <a:effectRef idx="2">
+            <a:schemeClr val="accent1"/>
+          </a:effectRef>
+          <a:fontRef idx="minor">
+            <a:schemeClr val="lt1"/>
+          </a:fontRef>
+        </p:style>
+        <p:txBody>
+          <a:bodyPr rtlCol="0" anchor="ctr"/>
+          <a:lstStyle/>
+          <a:p>
+            <a:pPr algn="ctr"/>
+          </a:p>
+        </p:txBody>
+      </p:sp>
+      <p:sp>
+        <p:nvSpPr>
+          <p:cNvPr id="78" name="Rectangle 77"/>
+          <p:cNvSpPr/>
+          <p:nvPr/>
+        </p:nvSpPr>
+        <p:spPr>
+          <a:xfrm>
+            <a:off x="246888" y="4559198"/>
+            <a:ext cx="2240279" cy="241401"/>
+          </a:xfrm>
+          <a:prstGeom prst="rect">
+            <a:avLst/>
+          </a:prstGeom>
+          <a:noFill/>
+          <a:ln>
+            <a:noFill/>
+          </a:ln>
+          <a:effectLst/>
+        </p:spPr>
+        <p:style>
+          <a:lnRef idx="1">
+            <a:schemeClr val="accent1"/>
+          </a:lnRef>
+          <a:fillRef idx="3">
+            <a:schemeClr val="accent1"/>
+          </a:fillRef>
+          <a:effectRef idx="2">
+            <a:schemeClr val="accent1"/>
+          </a:effectRef>
+          <a:fontRef idx="minor">
+            <a:schemeClr val="lt1"/>
+          </a:fontRef>
+        </p:style>
+        <p:txBody>
+          <a:bodyPr rtlCol="0" anchor="ctr" wrap="none" lIns="0" rIns="0" tIns="0" bIns="0"/>
+          <a:lstStyle/>
+          <a:p>
+            <a:pPr algn="l"/>
+            <a:r>
+              <a:rPr sz="900" b="1">
+                <a:solidFill>
+                  <a:srgbClr val="1A2B35"/>
+                </a:solidFill>
+                <a:latin typeface="Trebuchet MS"/>
+              </a:rPr>
+              <a:t>E. StatsBomb overlap, Δ=duży</a:t>
+            </a:r>
+          </a:p>
+        </p:txBody>
+      </p:sp>
+      <p:sp>
+        <p:nvSpPr>
+          <p:cNvPr id="79" name="Rectangle 78"/>
+          <p:cNvSpPr/>
+          <p:nvPr/>
+        </p:nvSpPr>
+        <p:spPr>
+          <a:xfrm>
+            <a:off x="2532888" y="4559198"/>
+            <a:ext cx="594360" cy="241401"/>
+          </a:xfrm>
+          <a:prstGeom prst="rect">
+            <a:avLst/>
+          </a:prstGeom>
+          <a:solidFill>
+            <a:srgbClr val="FFFFFF"/>
+          </a:solidFill>
+          <a:ln w="12700">
+            <a:solidFill>
+              <a:srgbClr val="D8E6EA"/>
+            </a:solidFill>
+          </a:ln>
+          <a:effectLst/>
+        </p:spPr>
+        <p:style>
+          <a:lnRef idx="1">
+            <a:schemeClr val="accent1"/>
+          </a:lnRef>
+          <a:fillRef idx="3">
+            <a:schemeClr val="accent1"/>
+          </a:fillRef>
+          <a:effectRef idx="2">
+            <a:schemeClr val="accent1"/>
+          </a:effectRef>
+          <a:fontRef idx="minor">
+            <a:schemeClr val="lt1"/>
+          </a:fontRef>
+        </p:style>
+        <p:txBody>
+          <a:bodyPr rtlCol="0" anchor="ctr"/>
+          <a:lstStyle/>
+          <a:p>
+            <a:pPr algn="ctr"/>
+          </a:p>
+        </p:txBody>
+      </p:sp>
+      <p:sp>
+        <p:nvSpPr>
+          <p:cNvPr id="80" name="Rectangle 79"/>
+          <p:cNvSpPr/>
+          <p:nvPr/>
+        </p:nvSpPr>
+        <p:spPr>
+          <a:xfrm>
+            <a:off x="2578608" y="4559198"/>
+            <a:ext cx="502920" cy="241401"/>
+          </a:xfrm>
+          <a:prstGeom prst="rect">
+            <a:avLst/>
+          </a:prstGeom>
+          <a:noFill/>
+          <a:ln>
+            <a:noFill/>
+          </a:ln>
+          <a:effectLst/>
+        </p:spPr>
+        <p:style>
+          <a:lnRef idx="1">
+            <a:schemeClr val="accent1"/>
+          </a:lnRef>
+          <a:fillRef idx="3">
+            <a:schemeClr val="accent1"/>
+          </a:fillRef>
+          <a:effectRef idx="2">
+            <a:schemeClr val="accent1"/>
+          </a:effectRef>
+          <a:fontRef idx="minor">
+            <a:schemeClr val="lt1"/>
+          </a:fontRef>
+        </p:style>
+        <p:txBody>
+          <a:bodyPr rtlCol="0" anchor="ctr" wrap="none" lIns="0" rIns="0" tIns="0" bIns="0"/>
+          <a:lstStyle/>
+          <a:p>
+            <a:pPr algn="ctr"/>
+            <a:r>
+              <a:rPr sz="900" b="0">
+                <a:solidFill>
+                  <a:srgbClr val="1A2B35"/>
+                </a:solidFill>
+                <a:latin typeface="Consolas"/>
+              </a:rPr>
+              <a:t>0.706</a:t>
+            </a:r>
+          </a:p>
+        </p:txBody>
+      </p:sp>
+      <p:sp>
+        <p:nvSpPr>
+          <p:cNvPr id="81" name="Rectangle 80"/>
+          <p:cNvSpPr/>
+          <p:nvPr/>
+        </p:nvSpPr>
+        <p:spPr>
+          <a:xfrm>
+            <a:off x="3127248" y="4559198"/>
+            <a:ext cx="960120" cy="241401"/>
+          </a:xfrm>
+          <a:prstGeom prst="rect">
+            <a:avLst/>
+          </a:prstGeom>
+          <a:solidFill>
+            <a:srgbClr val="FFFFFF"/>
+          </a:solidFill>
+          <a:ln w="12700">
+            <a:solidFill>
+              <a:srgbClr val="D8E6EA"/>
+            </a:solidFill>
+          </a:ln>
+          <a:effectLst/>
+        </p:spPr>
+        <p:style>
+          <a:lnRef idx="1">
+            <a:schemeClr val="accent1"/>
+          </a:lnRef>
+          <a:fillRef idx="3">
+            <a:schemeClr val="accent1"/>
+          </a:fillRef>
+          <a:effectRef idx="2">
+            <a:schemeClr val="accent1"/>
+          </a:effectRef>
+          <a:fontRef idx="minor">
+            <a:schemeClr val="lt1"/>
+          </a:fontRef>
+        </p:style>
+        <p:txBody>
+          <a:bodyPr rtlCol="0" anchor="ctr"/>
+          <a:lstStyle/>
+          <a:p>
+            <a:pPr algn="ctr"/>
+          </a:p>
+        </p:txBody>
+      </p:sp>
+      <p:sp>
+        <p:nvSpPr>
+          <p:cNvPr id="82" name="Rectangle 81"/>
+          <p:cNvSpPr/>
+          <p:nvPr/>
+        </p:nvSpPr>
+        <p:spPr>
+          <a:xfrm>
+            <a:off x="3172968" y="4559198"/>
+            <a:ext cx="868680" cy="241401"/>
+          </a:xfrm>
+          <a:prstGeom prst="rect">
+            <a:avLst/>
+          </a:prstGeom>
+          <a:noFill/>
+          <a:ln>
+            <a:noFill/>
+          </a:ln>
+          <a:effectLst/>
+        </p:spPr>
+        <p:style>
+          <a:lnRef idx="1">
+            <a:schemeClr val="accent1"/>
+          </a:lnRef>
+          <a:fillRef idx="3">
+            <a:schemeClr val="accent1"/>
+          </a:fillRef>
+          <a:effectRef idx="2">
+            <a:schemeClr val="accent1"/>
+          </a:effectRef>
+          <a:fontRef idx="minor">
+            <a:schemeClr val="lt1"/>
+          </a:fontRef>
+        </p:style>
+        <p:txBody>
+          <a:bodyPr rtlCol="0" anchor="ctr" wrap="none" lIns="0" rIns="0" tIns="0" bIns="0"/>
+          <a:lstStyle/>
+          <a:p>
+            <a:pPr algn="ctr"/>
+            <a:r>
+              <a:rPr sz="900" b="0">
+                <a:solidFill>
+                  <a:srgbClr val="1A2B35"/>
+                </a:solidFill>
+                <a:latin typeface="Consolas"/>
+              </a:rPr>
+              <a:t>+0.0060</a:t>
+            </a:r>
+          </a:p>
+        </p:txBody>
+      </p:sp>
+      <p:sp>
+        <p:nvSpPr>
+          <p:cNvPr id="83" name="Rectangle 82"/>
+          <p:cNvSpPr/>
+          <p:nvPr/>
+        </p:nvSpPr>
+        <p:spPr>
+          <a:xfrm>
+            <a:off x="4087368" y="4559198"/>
+            <a:ext cx="777240" cy="241401"/>
+          </a:xfrm>
+          <a:prstGeom prst="rect">
+            <a:avLst/>
+          </a:prstGeom>
+          <a:solidFill>
+            <a:srgbClr val="FFFFFF"/>
+          </a:solidFill>
+          <a:ln w="12700">
+            <a:solidFill>
+              <a:srgbClr val="D8E6EA"/>
+            </a:solidFill>
+          </a:ln>
+          <a:effectLst/>
+        </p:spPr>
+        <p:style>
+          <a:lnRef idx="1">
+            <a:schemeClr val="accent1"/>
+          </a:lnRef>
+          <a:fillRef idx="3">
+            <a:schemeClr val="accent1"/>
+          </a:fillRef>
+          <a:effectRef idx="2">
+            <a:schemeClr val="accent1"/>
+          </a:effectRef>
+          <a:fontRef idx="minor">
+            <a:schemeClr val="lt1"/>
+          </a:fontRef>
+        </p:style>
+        <p:txBody>
+          <a:bodyPr rtlCol="0" anchor="ctr"/>
+          <a:lstStyle/>
+          <a:p>
+            <a:pPr algn="ctr"/>
+          </a:p>
+        </p:txBody>
+      </p:sp>
+      <p:sp>
+        <p:nvSpPr>
+          <p:cNvPr id="84" name="Rectangle 83"/>
+          <p:cNvSpPr/>
+          <p:nvPr/>
+        </p:nvSpPr>
+        <p:spPr>
+          <a:xfrm>
+            <a:off x="4133087" y="4559198"/>
+            <a:ext cx="685800" cy="241401"/>
+          </a:xfrm>
+          <a:prstGeom prst="rect">
+            <a:avLst/>
+          </a:prstGeom>
+          <a:noFill/>
+          <a:ln>
+            <a:noFill/>
+          </a:ln>
+          <a:effectLst/>
+        </p:spPr>
+        <p:style>
+          <a:lnRef idx="1">
+            <a:schemeClr val="accent1"/>
+          </a:lnRef>
+          <a:fillRef idx="3">
+            <a:schemeClr val="accent1"/>
+          </a:fillRef>
+          <a:effectRef idx="2">
+            <a:schemeClr val="accent1"/>
+          </a:effectRef>
+          <a:fontRef idx="minor">
+            <a:schemeClr val="lt1"/>
+          </a:fontRef>
+        </p:style>
+        <p:txBody>
+          <a:bodyPr rtlCol="0" anchor="ctr" wrap="none" lIns="0" rIns="0" tIns="0" bIns="0"/>
+          <a:lstStyle/>
+          <a:p>
+            <a:pPr algn="ctr"/>
+            <a:r>
+              <a:rPr sz="900" b="1">
+                <a:solidFill>
+                  <a:srgbClr val="7C60D4"/>
+                </a:solidFill>
+                <a:latin typeface="Trebuchet MS"/>
+              </a:rPr>
+              <a:t>0.06652</a:t>
+            </a:r>
+          </a:p>
+        </p:txBody>
+      </p:sp>
+      <p:sp>
+        <p:nvSpPr>
+          <p:cNvPr id="85" name="Rectangle 84"/>
+          <p:cNvSpPr/>
+          <p:nvPr/>
+        </p:nvSpPr>
+        <p:spPr>
+          <a:xfrm>
+            <a:off x="4864607" y="4559198"/>
+            <a:ext cx="1600200" cy="241401"/>
+          </a:xfrm>
+          <a:prstGeom prst="rect">
+            <a:avLst/>
+          </a:prstGeom>
+          <a:solidFill>
+            <a:srgbClr val="FFFFFF"/>
+          </a:solidFill>
+          <a:ln w="12700">
+            <a:solidFill>
+              <a:srgbClr val="D8E6EA"/>
+            </a:solidFill>
+          </a:ln>
+          <a:effectLst/>
+        </p:spPr>
+        <p:style>
+          <a:lnRef idx="1">
+            <a:schemeClr val="accent1"/>
+          </a:lnRef>
+          <a:fillRef idx="3">
+            <a:schemeClr val="accent1"/>
+          </a:fillRef>
+          <a:effectRef idx="2">
+            <a:schemeClr val="accent1"/>
+          </a:effectRef>
+          <a:fontRef idx="minor">
+            <a:schemeClr val="lt1"/>
+          </a:fontRef>
+        </p:style>
+        <p:txBody>
+          <a:bodyPr rtlCol="0" anchor="ctr"/>
+          <a:lstStyle/>
+          <a:p>
+            <a:pPr algn="ctr"/>
+          </a:p>
+        </p:txBody>
+      </p:sp>
+      <p:sp>
+        <p:nvSpPr>
+          <p:cNvPr id="86" name="Rectangle 85"/>
+          <p:cNvSpPr/>
+          <p:nvPr/>
+        </p:nvSpPr>
+        <p:spPr>
+          <a:xfrm>
+            <a:off x="4910327" y="4559198"/>
+            <a:ext cx="1508760" cy="241401"/>
+          </a:xfrm>
+          <a:prstGeom prst="rect">
+            <a:avLst/>
+          </a:prstGeom>
+          <a:noFill/>
+          <a:ln>
+            <a:noFill/>
+          </a:ln>
+          <a:effectLst/>
+        </p:spPr>
+        <p:style>
+          <a:lnRef idx="1">
+            <a:schemeClr val="accent1"/>
+          </a:lnRef>
+          <a:fillRef idx="3">
+            <a:schemeClr val="accent1"/>
+          </a:fillRef>
+          <a:effectRef idx="2">
+            <a:schemeClr val="accent1"/>
+          </a:effectRef>
+          <a:fontRef idx="minor">
+            <a:schemeClr val="lt1"/>
+          </a:fontRef>
+        </p:style>
+        <p:txBody>
+          <a:bodyPr rtlCol="0" anchor="ctr" wrap="none" lIns="0" rIns="0" tIns="0" bIns="0"/>
+          <a:lstStyle/>
+          <a:p>
+            <a:pPr algn="ctr"/>
+            <a:r>
+              <a:rPr sz="850" b="0">
+                <a:solidFill>
+                  <a:srgbClr val="1A2B35"/>
+                </a:solidFill>
+                <a:latin typeface="Consolas"/>
+              </a:rPr>
+              <a:t>[0.0628, 0.0704]</a:t>
+            </a:r>
+          </a:p>
+        </p:txBody>
+      </p:sp>
+      <p:sp>
+        <p:nvSpPr>
+          <p:cNvPr id="87" name="Rectangle 86"/>
+          <p:cNvSpPr/>
+          <p:nvPr/>
+        </p:nvSpPr>
+        <p:spPr>
+          <a:xfrm>
+            <a:off x="6464807" y="4559198"/>
+            <a:ext cx="1234440" cy="241401"/>
+          </a:xfrm>
+          <a:prstGeom prst="rect">
+            <a:avLst/>
+          </a:prstGeom>
+          <a:solidFill>
+            <a:srgbClr val="FFFFFF"/>
+          </a:solidFill>
+          <a:ln w="12700">
+            <a:solidFill>
+              <a:srgbClr val="D8E6EA"/>
+            </a:solidFill>
+          </a:ln>
+          <a:effectLst/>
+        </p:spPr>
+        <p:style>
+          <a:lnRef idx="1">
+            <a:schemeClr val="accent1"/>
+          </a:lnRef>
+          <a:fillRef idx="3">
+            <a:schemeClr val="accent1"/>
+          </a:fillRef>
+          <a:effectRef idx="2">
+            <a:schemeClr val="accent1"/>
+          </a:effectRef>
+          <a:fontRef idx="minor">
+            <a:schemeClr val="lt1"/>
+          </a:fontRef>
+        </p:style>
+        <p:txBody>
+          <a:bodyPr rtlCol="0" anchor="ctr"/>
+          <a:lstStyle/>
+          <a:p>
+            <a:pPr algn="ctr"/>
+          </a:p>
+        </p:txBody>
+      </p:sp>
+      <p:sp>
+        <p:nvSpPr>
+          <p:cNvPr id="88" name="Rectangle 87"/>
+          <p:cNvSpPr/>
+          <p:nvPr/>
+        </p:nvSpPr>
+        <p:spPr>
+          <a:xfrm>
+            <a:off x="6510527" y="4559198"/>
+            <a:ext cx="1143000" cy="241401"/>
+          </a:xfrm>
+          <a:prstGeom prst="rect">
+            <a:avLst/>
+          </a:prstGeom>
+          <a:noFill/>
+          <a:ln>
+            <a:noFill/>
+          </a:ln>
+          <a:effectLst/>
+        </p:spPr>
+        <p:style>
+          <a:lnRef idx="1">
+            <a:schemeClr val="accent1"/>
+          </a:lnRef>
+          <a:fillRef idx="3">
+            <a:schemeClr val="accent1"/>
+          </a:fillRef>
+          <a:effectRef idx="2">
+            <a:schemeClr val="accent1"/>
+          </a:effectRef>
+          <a:fontRef idx="minor">
+            <a:schemeClr val="lt1"/>
+          </a:fontRef>
+        </p:style>
+        <p:txBody>
+          <a:bodyPr rtlCol="0" anchor="ctr" wrap="none" lIns="0" rIns="0" tIns="0" bIns="0"/>
+          <a:lstStyle/>
+          <a:p>
+            <a:pPr algn="ctr"/>
+            <a:r>
+              <a:rPr sz="900" b="1">
+                <a:solidFill>
+                  <a:srgbClr val="C0392B"/>
+                </a:solidFill>
+                <a:latin typeface="Trebuchet MS"/>
+              </a:rPr>
+              <a:t>nie</a:t>
+            </a:r>
+          </a:p>
+        </p:txBody>
+      </p:sp>
+      <p:sp>
+        <p:nvSpPr>
+          <p:cNvPr id="89" name="Rectangle 88"/>
+          <p:cNvSpPr/>
+          <p:nvPr/>
+        </p:nvSpPr>
+        <p:spPr>
+          <a:xfrm>
+            <a:off x="7699248" y="4559198"/>
+            <a:ext cx="1243584" cy="241401"/>
+          </a:xfrm>
+          <a:prstGeom prst="rect">
+            <a:avLst/>
+          </a:prstGeom>
+          <a:solidFill>
+            <a:srgbClr val="FFFFFF"/>
+          </a:solidFill>
+          <a:ln w="12700">
+            <a:solidFill>
+              <a:srgbClr val="D8E6EA"/>
+            </a:solidFill>
+          </a:ln>
+          <a:effectLst/>
+        </p:spPr>
+        <p:style>
+          <a:lnRef idx="1">
+            <a:schemeClr val="accent1"/>
+          </a:lnRef>
+          <a:fillRef idx="3">
+            <a:schemeClr val="accent1"/>
+          </a:fillRef>
+          <a:effectRef idx="2">
+            <a:schemeClr val="accent1"/>
+          </a:effectRef>
+          <a:fontRef idx="minor">
+            <a:schemeClr val="lt1"/>
+          </a:fontRef>
+        </p:style>
+        <p:txBody>
+          <a:bodyPr rtlCol="0" anchor="ctr"/>
+          <a:lstStyle/>
+          <a:p>
+            <a:pPr algn="ctr"/>
+          </a:p>
+        </p:txBody>
+      </p:sp>
+      <p:sp>
+        <p:nvSpPr>
+          <p:cNvPr id="90" name="Rectangle 89"/>
+          <p:cNvSpPr/>
+          <p:nvPr/>
+        </p:nvSpPr>
+        <p:spPr>
+          <a:xfrm>
+            <a:off x="7744968" y="4559198"/>
+            <a:ext cx="1152144" cy="241401"/>
+          </a:xfrm>
+          <a:prstGeom prst="rect">
+            <a:avLst/>
+          </a:prstGeom>
+          <a:noFill/>
+          <a:ln>
+            <a:noFill/>
+          </a:ln>
+          <a:effectLst/>
+        </p:spPr>
+        <p:style>
+          <a:lnRef idx="1">
+            <a:schemeClr val="accent1"/>
+          </a:lnRef>
+          <a:fillRef idx="3">
+            <a:schemeClr val="accent1"/>
+          </a:fillRef>
+          <a:effectRef idx="2">
+            <a:schemeClr val="accent1"/>
+          </a:effectRef>
+          <a:fontRef idx="minor">
+            <a:schemeClr val="lt1"/>
+          </a:fontRef>
+        </p:style>
+        <p:txBody>
+          <a:bodyPr rtlCol="0" anchor="ctr" wrap="none" lIns="0" rIns="0" tIns="0" bIns="0"/>
+          <a:lstStyle/>
+          <a:p>
+            <a:pPr algn="ctr"/>
+            <a:r>
+              <a:rPr sz="900" b="1">
+                <a:solidFill>
+                  <a:srgbClr val="2D9E4F"/>
+                </a:solidFill>
+                <a:latin typeface="Trebuchet MS"/>
+              </a:rPr>
+              <a:t>tak</a:t>
+            </a:r>
+          </a:p>
+        </p:txBody>
+      </p:sp>
+      <p:sp>
+        <p:nvSpPr>
+          <p:cNvPr id="91" name="Rectangle 90"/>
+          <p:cNvSpPr/>
+          <p:nvPr/>
+        </p:nvSpPr>
+        <p:spPr>
+          <a:xfrm>
+            <a:off x="201168" y="4828032"/>
+            <a:ext cx="8741664" cy="256032"/>
+          </a:xfrm>
+          <a:prstGeom prst="rect">
+            <a:avLst/>
+          </a:prstGeom>
+          <a:noFill/>
+          <a:ln>
+            <a:noFill/>
+          </a:ln>
+          <a:effectLst/>
+        </p:spPr>
+        <p:style>
+          <a:lnRef idx="1">
+            <a:schemeClr val="accent1"/>
+          </a:lnRef>
+          <a:fillRef idx="3">
+            <a:schemeClr val="accent1"/>
+          </a:fillRef>
+          <a:effectRef idx="2">
+            <a:schemeClr val="accent1"/>
+          </a:effectRef>
+          <a:fontRef idx="minor">
+            <a:schemeClr val="lt1"/>
+          </a:fontRef>
+        </p:style>
+        <p:txBody>
+          <a:bodyPr rtlCol="0" anchor="ctr" wrap="none" lIns="0" rIns="0" tIns="0" bIns="0"/>
+          <a:lstStyle/>
+          <a:p>
+            <a:pPr algn="l"/>
+            <a:r>
+              <a:rPr sz="950" b="0">
+                <a:solidFill>
+                  <a:srgbClr val="6B8899"/>
+                </a:solidFill>
+                <a:latin typeface="Calibri"/>
+              </a:rPr>
+              <a:t>C i E mają ten sam ESS=0.706 (≈ StatsBomb 0.686), ale różny wynik → estymator ma moc detekcji  ·  D odtwarza wzorzec StatsBomb (CI zawiera V* i naive)</a:t>
+            </a:r>
           </a:p>
         </p:txBody>
       </p:sp>

</xml_diff>